<commit_message>
chore(deck): update live public HTTPS prototype link and re-export PDF
</commit_message>
<xml_diff>
--- a/docs/EcoLoop_AI_Pitch_Deck.pptx
+++ b/docs/EcoLoop_AI_Pitch_Deck.pptx
@@ -7419,6 +7419,41 @@
                 </a:solidFill>
               </a:defRPr>
             </a:pPr>
+          </a:p>
+        </p:txBody>
+      </p:sp>
+      <p:sp>
+        <p:nvSpPr>
+          <p:cNvPr id="130" name="TextBox 129"/>
+          <p:cNvSpPr txBox="1"/>
+          <p:nvPr/>
+        </p:nvSpPr>
+        <p:spPr>
+          <a:xfrm>
+            <a:off x="731520" y="1097280"/>
+            <a:ext cx="7680960" cy="4572000"/>
+          </a:xfrm>
+          <a:prstGeom prst="rect">
+            <a:avLst/>
+          </a:prstGeom>
+          <a:noFill/>
+        </p:spPr>
+        <p:txBody>
+          <a:bodyPr wrap="square">
+            <a:spAutoFit/>
+          </a:bodyPr>
+          <a:lstStyle/>
+          <a:p>
+            <a:pPr>
+              <a:spcAft>
+                <a:spcPts val="1200"/>
+              </a:spcAft>
+              <a:defRPr b="1" sz="2000">
+                <a:solidFill>
+                  <a:srgbClr val="047857"/>
+                </a:solidFill>
+              </a:defRPr>
+            </a:pPr>
             <a:r>
               <a:t>Estimated Implementation &amp; Operating Cost</a:t>
             </a:r>
@@ -7767,21 +7802,6 @@
                 </a:solidFill>
               </a:defRPr>
             </a:pPr>
-            <a:r>
-              <a:t>Snapshots of the Working Prototype</a:t>
-            </a:r>
-          </a:p>
-          <a:p>
-            <a:pPr>
-              <a:defRPr sz="1100">
-                <a:solidFill>
-                  <a:srgbClr val="64748B"/>
-                </a:solidFill>
-              </a:defRPr>
-            </a:pPr>
-            <a:r>
-              <a:t>Multimodal Gemini 2.5 Scanner • Malayalam Localization • Collector Portal • Auditable Impact Ledger</a:t>
-            </a:r>
           </a:p>
         </p:txBody>
       </p:sp>
@@ -7860,6 +7880,149 @@
       <p:pic>
         <p:nvPicPr>
           <p:cNvPr id="141" name="Picture 140" descr="impact_dashboard_metrics_1792332824611.png"/>
+          <p:cNvPicPr>
+            <a:picLocks noChangeAspect="1"/>
+          </p:cNvPicPr>
+          <p:nvPr/>
+        </p:nvPicPr>
+        <p:blipFill>
+          <a:blip r:embed="rId8"/>
+          <a:stretch>
+            <a:fillRect/>
+          </a:stretch>
+        </p:blipFill>
+        <p:spPr>
+          <a:xfrm>
+            <a:off x="4663440" y="3108960"/>
+            <a:ext cx="3840480" cy="1783080"/>
+          </a:xfrm>
+          <a:prstGeom prst="rect">
+            <a:avLst/>
+          </a:prstGeom>
+        </p:spPr>
+      </p:pic>
+      <p:sp>
+        <p:nvSpPr>
+          <p:cNvPr id="142" name="TextBox 141"/>
+          <p:cNvSpPr txBox="1"/>
+          <p:nvPr/>
+        </p:nvSpPr>
+        <p:spPr>
+          <a:xfrm>
+            <a:off x="548640" y="365760"/>
+            <a:ext cx="8046720" cy="731520"/>
+          </a:xfrm>
+          <a:prstGeom prst="rect">
+            <a:avLst/>
+          </a:prstGeom>
+          <a:noFill/>
+        </p:spPr>
+        <p:txBody>
+          <a:bodyPr wrap="square">
+            <a:spAutoFit/>
+          </a:bodyPr>
+          <a:lstStyle/>
+          <a:p>
+            <a:pPr>
+              <a:defRPr b="1" sz="2200">
+                <a:solidFill>
+                  <a:srgbClr val="047857"/>
+                </a:solidFill>
+              </a:defRPr>
+            </a:pPr>
+            <a:r>
+              <a:t>Snapshots of the Working Prototype</a:t>
+            </a:r>
+          </a:p>
+          <a:p>
+            <a:pPr>
+              <a:defRPr sz="1100">
+                <a:solidFill>
+                  <a:srgbClr val="64748B"/>
+                </a:solidFill>
+              </a:defRPr>
+            </a:pPr>
+            <a:r>
+              <a:t>Multimodal Gemini 2.5 Scanner • Malayalam Localization • Collector Portal • Auditable Impact Ledger</a:t>
+            </a:r>
+          </a:p>
+        </p:txBody>
+      </p:sp>
+      <p:pic>
+        <p:nvPicPr>
+          <p:cNvPr id="143" name="Picture 142" descr="image.png"/>
+          <p:cNvPicPr>
+            <a:picLocks noChangeAspect="1"/>
+          </p:cNvPicPr>
+          <p:nvPr/>
+        </p:nvPicPr>
+        <p:blipFill>
+          <a:blip r:embed="rId5"/>
+          <a:stretch>
+            <a:fillRect/>
+          </a:stretch>
+        </p:blipFill>
+        <p:spPr>
+          <a:xfrm>
+            <a:off x="548640" y="1188720"/>
+            <a:ext cx="3840480" cy="1783080"/>
+          </a:xfrm>
+          <a:prstGeom prst="rect">
+            <a:avLst/>
+          </a:prstGeom>
+        </p:spPr>
+      </p:pic>
+      <p:pic>
+        <p:nvPicPr>
+          <p:cNvPr id="144" name="Picture 143" descr="image.png"/>
+          <p:cNvPicPr>
+            <a:picLocks noChangeAspect="1"/>
+          </p:cNvPicPr>
+          <p:nvPr/>
+        </p:nvPicPr>
+        <p:blipFill>
+          <a:blip r:embed="rId6"/>
+          <a:stretch>
+            <a:fillRect/>
+          </a:stretch>
+        </p:blipFill>
+        <p:spPr>
+          <a:xfrm>
+            <a:off x="4663440" y="1188720"/>
+            <a:ext cx="3840480" cy="1783080"/>
+          </a:xfrm>
+          <a:prstGeom prst="rect">
+            <a:avLst/>
+          </a:prstGeom>
+        </p:spPr>
+      </p:pic>
+      <p:pic>
+        <p:nvPicPr>
+          <p:cNvPr id="145" name="Picture 144" descr="image.png"/>
+          <p:cNvPicPr>
+            <a:picLocks noChangeAspect="1"/>
+          </p:cNvPicPr>
+          <p:nvPr/>
+        </p:nvPicPr>
+        <p:blipFill>
+          <a:blip r:embed="rId7"/>
+          <a:stretch>
+            <a:fillRect/>
+          </a:stretch>
+        </p:blipFill>
+        <p:spPr>
+          <a:xfrm>
+            <a:off x="548640" y="3108960"/>
+            <a:ext cx="3840480" cy="1783080"/>
+          </a:xfrm>
+          <a:prstGeom prst="rect">
+            <a:avLst/>
+          </a:prstGeom>
+        </p:spPr>
+      </p:pic>
+      <p:pic>
+        <p:nvPicPr>
+          <p:cNvPr id="146" name="Picture 145" descr="image.png"/>
           <p:cNvPicPr>
             <a:picLocks noChangeAspect="1"/>
           </p:cNvPicPr>
@@ -8111,6 +8274,41 @@
                 </a:solidFill>
               </a:defRPr>
             </a:pPr>
+          </a:p>
+        </p:txBody>
+      </p:sp>
+      <p:sp>
+        <p:nvSpPr>
+          <p:cNvPr id="146" name="TextBox 145"/>
+          <p:cNvSpPr txBox="1"/>
+          <p:nvPr/>
+        </p:nvSpPr>
+        <p:spPr>
+          <a:xfrm>
+            <a:off x="731520" y="1097280"/>
+            <a:ext cx="7680960" cy="4572000"/>
+          </a:xfrm>
+          <a:prstGeom prst="rect">
+            <a:avLst/>
+          </a:prstGeom>
+          <a:noFill/>
+        </p:spPr>
+        <p:txBody>
+          <a:bodyPr wrap="square">
+            <a:spAutoFit/>
+          </a:bodyPr>
+          <a:lstStyle/>
+          <a:p>
+            <a:pPr>
+              <a:spcAft>
+                <a:spcPts val="1200"/>
+              </a:spcAft>
+              <a:defRPr b="1" sz="2000">
+                <a:solidFill>
+                  <a:srgbClr val="047857"/>
+                </a:solidFill>
+              </a:defRPr>
+            </a:pPr>
             <a:r>
               <a:t>Prototype Performance &amp; Quality Benchmarks</a:t>
             </a:r>
@@ -8462,6 +8660,41 @@
                 </a:solidFill>
               </a:defRPr>
             </a:pPr>
+          </a:p>
+        </p:txBody>
+      </p:sp>
+      <p:sp>
+        <p:nvSpPr>
+          <p:cNvPr id="154" name="TextBox 153"/>
+          <p:cNvSpPr txBox="1"/>
+          <p:nvPr/>
+        </p:nvSpPr>
+        <p:spPr>
+          <a:xfrm>
+            <a:off x="731520" y="1097280"/>
+            <a:ext cx="7680960" cy="4572000"/>
+          </a:xfrm>
+          <a:prstGeom prst="rect">
+            <a:avLst/>
+          </a:prstGeom>
+          <a:noFill/>
+        </p:spPr>
+        <p:txBody>
+          <a:bodyPr wrap="square">
+            <a:spAutoFit/>
+          </a:bodyPr>
+          <a:lstStyle/>
+          <a:p>
+            <a:pPr>
+              <a:spcAft>
+                <a:spcPts val="1200"/>
+              </a:spcAft>
+              <a:defRPr b="1" sz="2000">
+                <a:solidFill>
+                  <a:srgbClr val="047857"/>
+                </a:solidFill>
+              </a:defRPr>
+            </a:pPr>
             <a:r>
               <a:t>Future Development &amp; Commercial Roadmap</a:t>
             </a:r>
@@ -8790,6 +9023,41 @@
                 </a:solidFill>
               </a:defRPr>
             </a:pPr>
+          </a:p>
+        </p:txBody>
+      </p:sp>
+      <p:sp>
+        <p:nvSpPr>
+          <p:cNvPr id="162" name="TextBox 161"/>
+          <p:cNvSpPr txBox="1"/>
+          <p:nvPr/>
+        </p:nvSpPr>
+        <p:spPr>
+          <a:xfrm>
+            <a:off x="731520" y="914400"/>
+            <a:ext cx="7680960" cy="4572000"/>
+          </a:xfrm>
+          <a:prstGeom prst="rect">
+            <a:avLst/>
+          </a:prstGeom>
+          <a:noFill/>
+        </p:spPr>
+        <p:txBody>
+          <a:bodyPr wrap="square">
+            <a:spAutoFit/>
+          </a:bodyPr>
+          <a:lstStyle/>
+          <a:p>
+            <a:pPr>
+              <a:spcAft>
+                <a:spcPts val="1200"/>
+              </a:spcAft>
+              <a:defRPr b="1" sz="2000">
+                <a:solidFill>
+                  <a:srgbClr val="047857"/>
+                </a:solidFill>
+              </a:defRPr>
+            </a:pPr>
             <a:r>
               <a:t>Official Submission Links</a:t>
             </a:r>
@@ -8814,7 +9082,7 @@
                   <a:srgbClr val="1E293B"/>
                 </a:solidFill>
               </a:rPr>
-              <a:t>https://ecoloop-ai.loca.lt (Public HTTPS tunnel to live Next.js server; IP Bypass: 103.182.167.72)</a:t>
+              <a:t>https://3901e40689d1c1.lhr.life (Live Public HTTPS Prototype — zero password/interstitials)</a:t>
             </a:r>
           </a:p>
           <a:p>
@@ -9167,6 +9435,41 @@
                 </a:solidFill>
               </a:defRPr>
             </a:pPr>
+          </a:p>
+        </p:txBody>
+      </p:sp>
+      <p:sp>
+        <p:nvSpPr>
+          <p:cNvPr id="169" name="TextBox 168"/>
+          <p:cNvSpPr txBox="1"/>
+          <p:nvPr/>
+        </p:nvSpPr>
+        <p:spPr>
+          <a:xfrm>
+            <a:off x="731520" y="1097280"/>
+            <a:ext cx="7680960" cy="4572000"/>
+          </a:xfrm>
+          <a:prstGeom prst="rect">
+            <a:avLst/>
+          </a:prstGeom>
+          <a:noFill/>
+        </p:spPr>
+        <p:txBody>
+          <a:bodyPr wrap="square">
+            <a:spAutoFit/>
+          </a:bodyPr>
+          <a:lstStyle/>
+          <a:p>
+            <a:pPr>
+              <a:spcAft>
+                <a:spcPts val="1200"/>
+              </a:spcAft>
+              <a:defRPr b="1" sz="2000">
+                <a:solidFill>
+                  <a:srgbClr val="047857"/>
+                </a:solidFill>
+              </a:defRPr>
+            </a:pPr>
             <a:r>
               <a:t>Why EcoLoop AI Wins the AI Builder Cup</a:t>
             </a:r>
@@ -9412,6 +9715,41 @@
                 </a:solidFill>
               </a:defRPr>
             </a:pPr>
+          </a:p>
+        </p:txBody>
+      </p:sp>
+      <p:sp>
+        <p:nvSpPr>
+          <p:cNvPr id="175" name="TextBox 174"/>
+          <p:cNvSpPr txBox="1"/>
+          <p:nvPr/>
+        </p:nvSpPr>
+        <p:spPr>
+          <a:xfrm>
+            <a:off x="1371600" y="2011680"/>
+            <a:ext cx="6400800" cy="2743200"/>
+          </a:xfrm>
+          <a:prstGeom prst="rect">
+            <a:avLst/>
+          </a:prstGeom>
+          <a:noFill/>
+        </p:spPr>
+        <p:txBody>
+          <a:bodyPr wrap="square">
+            <a:spAutoFit/>
+          </a:bodyPr>
+          <a:lstStyle/>
+          <a:p>
+            <a:pPr>
+              <a:spcAft>
+                <a:spcPts val="1200"/>
+              </a:spcAft>
+              <a:defRPr b="1" sz="2000">
+                <a:solidFill>
+                  <a:srgbClr val="047857"/>
+                </a:solidFill>
+              </a:defRPr>
+            </a:pPr>
             <a:r>
               <a:t>EcoLoop AI — From Waste to Verified Value</a:t>
             </a:r>
@@ -9675,6 +10013,41 @@
       <p:sp>
         <p:nvSpPr>
           <p:cNvPr id="66" name="TextBox 65"/>
+          <p:cNvSpPr txBox="1"/>
+          <p:nvPr/>
+        </p:nvSpPr>
+        <p:spPr>
+          <a:xfrm>
+            <a:off x="731520" y="1097280"/>
+            <a:ext cx="7680960" cy="4572000"/>
+          </a:xfrm>
+          <a:prstGeom prst="rect">
+            <a:avLst/>
+          </a:prstGeom>
+          <a:noFill/>
+        </p:spPr>
+        <p:txBody>
+          <a:bodyPr wrap="square">
+            <a:spAutoFit/>
+          </a:bodyPr>
+          <a:lstStyle/>
+          <a:p>
+            <a:pPr>
+              <a:spcAft>
+                <a:spcPts val="1200"/>
+              </a:spcAft>
+              <a:defRPr b="1" sz="2000">
+                <a:solidFill>
+                  <a:srgbClr val="047857"/>
+                </a:solidFill>
+              </a:defRPr>
+            </a:pPr>
+          </a:p>
+        </p:txBody>
+      </p:sp>
+      <p:sp>
+        <p:nvSpPr>
+          <p:cNvPr id="67" name="TextBox 66"/>
           <p:cNvSpPr txBox="1"/>
           <p:nvPr/>
         </p:nvSpPr>
@@ -10005,6 +10378,41 @@
                 </a:solidFill>
               </a:defRPr>
             </a:pPr>
+          </a:p>
+        </p:txBody>
+      </p:sp>
+      <p:sp>
+        <p:nvSpPr>
+          <p:cNvPr id="74" name="TextBox 73"/>
+          <p:cNvSpPr txBox="1"/>
+          <p:nvPr/>
+        </p:nvSpPr>
+        <p:spPr>
+          <a:xfrm>
+            <a:off x="731520" y="1097280"/>
+            <a:ext cx="7680960" cy="4572000"/>
+          </a:xfrm>
+          <a:prstGeom prst="rect">
+            <a:avLst/>
+          </a:prstGeom>
+          <a:noFill/>
+        </p:spPr>
+        <p:txBody>
+          <a:bodyPr wrap="square">
+            <a:spAutoFit/>
+          </a:bodyPr>
+          <a:lstStyle/>
+          <a:p>
+            <a:pPr>
+              <a:spcAft>
+                <a:spcPts val="1200"/>
+              </a:spcAft>
+              <a:defRPr b="1" sz="2000">
+                <a:solidFill>
+                  <a:srgbClr val="047857"/>
+                </a:solidFill>
+              </a:defRPr>
+            </a:pPr>
             <a:r>
               <a:t>Brief About the Idea — EcoLoop AI</a:t>
             </a:r>
@@ -10310,6 +10718,41 @@
                 </a:solidFill>
               </a:defRPr>
             </a:pPr>
+          </a:p>
+        </p:txBody>
+      </p:sp>
+      <p:sp>
+        <p:nvSpPr>
+          <p:cNvPr id="82" name="TextBox 81"/>
+          <p:cNvSpPr txBox="1"/>
+          <p:nvPr/>
+        </p:nvSpPr>
+        <p:spPr>
+          <a:xfrm>
+            <a:off x="731520" y="1097280"/>
+            <a:ext cx="7680960" cy="4572000"/>
+          </a:xfrm>
+          <a:prstGeom prst="rect">
+            <a:avLst/>
+          </a:prstGeom>
+          <a:noFill/>
+        </p:spPr>
+        <p:txBody>
+          <a:bodyPr wrap="square">
+            <a:spAutoFit/>
+          </a:bodyPr>
+          <a:lstStyle/>
+          <a:p>
+            <a:pPr>
+              <a:spcAft>
+                <a:spcPts val="1200"/>
+              </a:spcAft>
+              <a:defRPr b="1" sz="2000">
+                <a:solidFill>
+                  <a:srgbClr val="047857"/>
+                </a:solidFill>
+              </a:defRPr>
+            </a:pPr>
             <a:r>
               <a:t>Opportunities &amp; Unique Selling Proposition (USP)</a:t>
             </a:r>
@@ -10661,6 +11104,41 @@
                 </a:solidFill>
               </a:defRPr>
             </a:pPr>
+          </a:p>
+        </p:txBody>
+      </p:sp>
+      <p:sp>
+        <p:nvSpPr>
+          <p:cNvPr id="90" name="TextBox 89"/>
+          <p:cNvSpPr txBox="1"/>
+          <p:nvPr/>
+        </p:nvSpPr>
+        <p:spPr>
+          <a:xfrm>
+            <a:off x="731520" y="1097280"/>
+            <a:ext cx="7680960" cy="4572000"/>
+          </a:xfrm>
+          <a:prstGeom prst="rect">
+            <a:avLst/>
+          </a:prstGeom>
+          <a:noFill/>
+        </p:spPr>
+        <p:txBody>
+          <a:bodyPr wrap="square">
+            <a:spAutoFit/>
+          </a:bodyPr>
+          <a:lstStyle/>
+          <a:p>
+            <a:pPr>
+              <a:spcAft>
+                <a:spcPts val="1200"/>
+              </a:spcAft>
+              <a:defRPr b="1" sz="2000">
+                <a:solidFill>
+                  <a:srgbClr val="047857"/>
+                </a:solidFill>
+              </a:defRPr>
+            </a:pPr>
             <a:r>
               <a:t>Key Features Offered by EcoLoop AI</a:t>
             </a:r>
@@ -11058,6 +11536,41 @@
                 </a:solidFill>
               </a:defRPr>
             </a:pPr>
+          </a:p>
+        </p:txBody>
+      </p:sp>
+      <p:sp>
+        <p:nvSpPr>
+          <p:cNvPr id="98" name="TextBox 97"/>
+          <p:cNvSpPr txBox="1"/>
+          <p:nvPr/>
+        </p:nvSpPr>
+        <p:spPr>
+          <a:xfrm>
+            <a:off x="731520" y="1097280"/>
+            <a:ext cx="7680960" cy="4572000"/>
+          </a:xfrm>
+          <a:prstGeom prst="rect">
+            <a:avLst/>
+          </a:prstGeom>
+          <a:noFill/>
+        </p:spPr>
+        <p:txBody>
+          <a:bodyPr wrap="square">
+            <a:spAutoFit/>
+          </a:bodyPr>
+          <a:lstStyle/>
+          <a:p>
+            <a:pPr>
+              <a:spcAft>
+                <a:spcPts val="1200"/>
+              </a:spcAft>
+              <a:defRPr b="1" sz="2000">
+                <a:solidFill>
+                  <a:srgbClr val="047857"/>
+                </a:solidFill>
+              </a:defRPr>
+            </a:pPr>
             <a:r>
               <a:t>Process Flow &amp; Use-Case Diagram</a:t>
             </a:r>
@@ -11455,124 +11968,6 @@
                 </a:solidFill>
               </a:defRPr>
             </a:pPr>
-            <a:r>
-              <a:t>UI Wireframes &amp; Component Hierarchy</a:t>
-            </a:r>
-          </a:p>
-          <a:p>
-            <a:pPr>
-              <a:spcAft>
-                <a:spcPts val="600"/>
-              </a:spcAft>
-            </a:pPr>
-            <a:r>
-              <a:rPr b="1" sz="1300">
-                <a:solidFill>
-                  <a:srgbClr val="1E293B"/>
-                </a:solidFill>
-              </a:rPr>
-              <a:t>• View 1 - AI Waste Scanner: </a:t>
-            </a:r>
-            <a:r>
-              <a:rPr sz="1300">
-                <a:solidFill>
-                  <a:srgbClr val="1E293B"/>
-                </a:solidFill>
-              </a:rPr>
-              <a:t>Hero banner, sample selector (Milma pouch, PET bottle, box, battery), real-time reasoning ticker.</a:t>
-            </a:r>
-          </a:p>
-          <a:p>
-            <a:pPr>
-              <a:spcAft>
-                <a:spcPts val="600"/>
-              </a:spcAft>
-            </a:pPr>
-            <a:r>
-              <a:rPr b="1" sz="1300">
-                <a:solidFill>
-                  <a:srgbClr val="1E293B"/>
-                </a:solidFill>
-              </a:rPr>
-              <a:t>• View 2 - Dynamic Guidance Card: </a:t>
-            </a:r>
-            <a:r>
-              <a:rPr sz="1300">
-                <a:solidFill>
-                  <a:srgbClr val="1E293B"/>
-                </a:solidFill>
-              </a:rPr>
-              <a:t>Certainty score badge, contamination alert, Suchitwa Mission cleaning/drying steps.</a:t>
-            </a:r>
-          </a:p>
-          <a:p>
-            <a:pPr>
-              <a:spcAft>
-                <a:spcPts val="600"/>
-              </a:spcAft>
-            </a:pPr>
-            <a:r>
-              <a:rPr b="1" sz="1300">
-                <a:solidFill>
-                  <a:srgbClr val="1E293B"/>
-                </a:solidFill>
-              </a:rPr>
-              <a:t>• View 3 - Kerala Recovery Hubs: </a:t>
-            </a:r>
-            <a:r>
-              <a:rPr sz="1300">
-                <a:solidFill>
-                  <a:srgbClr val="1E293B"/>
-                </a:solidFill>
-              </a:rPr>
-              <a:t>District and material category filters, collection calendars, facility addresses.</a:t>
-            </a:r>
-          </a:p>
-          <a:p>
-            <a:pPr>
-              <a:spcAft>
-                <a:spcPts val="600"/>
-              </a:spcAft>
-            </a:pPr>
-            <a:r>
-              <a:rPr b="1" sz="1300">
-                <a:solidFill>
-                  <a:srgbClr val="1E293B"/>
-                </a:solidFill>
-              </a:rPr>
-              <a:t>• View 4 - Collector Portal: </a:t>
-            </a:r>
-            <a:r>
-              <a:rPr sz="1300">
-                <a:solidFill>
-                  <a:srgbClr val="1E293B"/>
-                </a:solidFill>
-              </a:rPr>
-              <a:t>PIN-gated queue of pending pickups, certified scale weight entry, tamper-evident receipts.</a:t>
-            </a:r>
-          </a:p>
-          <a:p>
-            <a:pPr>
-              <a:spcAft>
-                <a:spcPts val="600"/>
-              </a:spcAft>
-            </a:pPr>
-            <a:r>
-              <a:rPr b="1" sz="1300">
-                <a:solidFill>
-                  <a:srgbClr val="1E293B"/>
-                </a:solidFill>
-              </a:rPr>
-              <a:t>• View 5 - Impact Ledger: </a:t>
-            </a:r>
-            <a:r>
-              <a:rPr sz="1300">
-                <a:solidFill>
-                  <a:srgbClr val="1E293B"/>
-                </a:solidFill>
-              </a:rPr>
-              <a:t>Verified landfill kg diverted, avoided CO2e, and live auditable handover feed.</a:t>
-            </a:r>
           </a:p>
         </p:txBody>
       </p:sp>
@@ -11603,6 +11998,207 @@
       <p:pic>
         <p:nvPicPr>
           <p:cNvPr id="107" name="Picture 106" descr="guidance_card_view_1792332769618.png"/>
+          <p:cNvPicPr>
+            <a:picLocks noChangeAspect="1"/>
+          </p:cNvPicPr>
+          <p:nvPr/>
+        </p:nvPicPr>
+        <p:blipFill>
+          <a:blip r:embed="rId6"/>
+          <a:stretch>
+            <a:fillRect/>
+          </a:stretch>
+        </p:blipFill>
+        <p:spPr>
+          <a:xfrm>
+            <a:off x="4754880" y="2926080"/>
+            <a:ext cx="3931920" cy="1828800"/>
+          </a:xfrm>
+          <a:prstGeom prst="rect">
+            <a:avLst/>
+          </a:prstGeom>
+        </p:spPr>
+      </p:pic>
+      <p:sp>
+        <p:nvSpPr>
+          <p:cNvPr id="108" name="TextBox 107"/>
+          <p:cNvSpPr txBox="1"/>
+          <p:nvPr/>
+        </p:nvSpPr>
+        <p:spPr>
+          <a:xfrm>
+            <a:off x="548640" y="914400"/>
+            <a:ext cx="4023360" cy="4023360"/>
+          </a:xfrm>
+          <a:prstGeom prst="rect">
+            <a:avLst/>
+          </a:prstGeom>
+          <a:noFill/>
+        </p:spPr>
+        <p:txBody>
+          <a:bodyPr wrap="square">
+            <a:spAutoFit/>
+          </a:bodyPr>
+          <a:lstStyle/>
+          <a:p>
+            <a:pPr>
+              <a:spcAft>
+                <a:spcPts val="1200"/>
+              </a:spcAft>
+              <a:defRPr b="1" sz="2000">
+                <a:solidFill>
+                  <a:srgbClr val="047857"/>
+                </a:solidFill>
+              </a:defRPr>
+            </a:pPr>
+            <a:r>
+              <a:t>UI Wireframes &amp; Component Hierarchy</a:t>
+            </a:r>
+          </a:p>
+          <a:p>
+            <a:pPr>
+              <a:spcAft>
+                <a:spcPts val="600"/>
+              </a:spcAft>
+            </a:pPr>
+            <a:r>
+              <a:rPr b="1" sz="1300">
+                <a:solidFill>
+                  <a:srgbClr val="1E293B"/>
+                </a:solidFill>
+              </a:rPr>
+              <a:t>• View 1 - AI Waste Scanner: </a:t>
+            </a:r>
+            <a:r>
+              <a:rPr sz="1300">
+                <a:solidFill>
+                  <a:srgbClr val="1E293B"/>
+                </a:solidFill>
+              </a:rPr>
+              <a:t>Hero banner, sample selector (Milma pouch, PET bottle, box, battery), real-time reasoning ticker.</a:t>
+            </a:r>
+          </a:p>
+          <a:p>
+            <a:pPr>
+              <a:spcAft>
+                <a:spcPts val="600"/>
+              </a:spcAft>
+            </a:pPr>
+            <a:r>
+              <a:rPr b="1" sz="1300">
+                <a:solidFill>
+                  <a:srgbClr val="1E293B"/>
+                </a:solidFill>
+              </a:rPr>
+              <a:t>• View 2 - Dynamic Guidance Card: </a:t>
+            </a:r>
+            <a:r>
+              <a:rPr sz="1300">
+                <a:solidFill>
+                  <a:srgbClr val="1E293B"/>
+                </a:solidFill>
+              </a:rPr>
+              <a:t>Certainty score badge, contamination alert, Suchitwa Mission cleaning/drying steps.</a:t>
+            </a:r>
+          </a:p>
+          <a:p>
+            <a:pPr>
+              <a:spcAft>
+                <a:spcPts val="600"/>
+              </a:spcAft>
+            </a:pPr>
+            <a:r>
+              <a:rPr b="1" sz="1300">
+                <a:solidFill>
+                  <a:srgbClr val="1E293B"/>
+                </a:solidFill>
+              </a:rPr>
+              <a:t>• View 3 - Kerala Recovery Hubs: </a:t>
+            </a:r>
+            <a:r>
+              <a:rPr sz="1300">
+                <a:solidFill>
+                  <a:srgbClr val="1E293B"/>
+                </a:solidFill>
+              </a:rPr>
+              <a:t>District and material category filters, collection calendars, facility addresses.</a:t>
+            </a:r>
+          </a:p>
+          <a:p>
+            <a:pPr>
+              <a:spcAft>
+                <a:spcPts val="600"/>
+              </a:spcAft>
+            </a:pPr>
+            <a:r>
+              <a:rPr b="1" sz="1300">
+                <a:solidFill>
+                  <a:srgbClr val="1E293B"/>
+                </a:solidFill>
+              </a:rPr>
+              <a:t>• View 4 - Collector Portal: </a:t>
+            </a:r>
+            <a:r>
+              <a:rPr sz="1300">
+                <a:solidFill>
+                  <a:srgbClr val="1E293B"/>
+                </a:solidFill>
+              </a:rPr>
+              <a:t>PIN-gated queue of pending pickups, certified scale weight entry, tamper-evident receipts.</a:t>
+            </a:r>
+          </a:p>
+          <a:p>
+            <a:pPr>
+              <a:spcAft>
+                <a:spcPts val="600"/>
+              </a:spcAft>
+            </a:pPr>
+            <a:r>
+              <a:rPr b="1" sz="1300">
+                <a:solidFill>
+                  <a:srgbClr val="1E293B"/>
+                </a:solidFill>
+              </a:rPr>
+              <a:t>• View 5 - Impact Ledger: </a:t>
+            </a:r>
+            <a:r>
+              <a:rPr sz="1300">
+                <a:solidFill>
+                  <a:srgbClr val="1E293B"/>
+                </a:solidFill>
+              </a:rPr>
+              <a:t>Verified landfill kg diverted, avoided CO2e, and live auditable handover feed.</a:t>
+            </a:r>
+          </a:p>
+        </p:txBody>
+      </p:sp>
+      <p:pic>
+        <p:nvPicPr>
+          <p:cNvPr id="109" name="Picture 108" descr="image.png"/>
+          <p:cNvPicPr>
+            <a:picLocks noChangeAspect="1"/>
+          </p:cNvPicPr>
+          <p:nvPr/>
+        </p:nvPicPr>
+        <p:blipFill>
+          <a:blip r:embed="rId5"/>
+          <a:stretch>
+            <a:fillRect/>
+          </a:stretch>
+        </p:blipFill>
+        <p:spPr>
+          <a:xfrm>
+            <a:off x="4754880" y="914400"/>
+            <a:ext cx="3931920" cy="1828800"/>
+          </a:xfrm>
+          <a:prstGeom prst="rect">
+            <a:avLst/>
+          </a:prstGeom>
+        </p:spPr>
+      </p:pic>
+      <p:pic>
+        <p:nvPicPr>
+          <p:cNvPr id="110" name="Picture 109" descr="image.png"/>
           <p:cNvPicPr>
             <a:picLocks noChangeAspect="1"/>
           </p:cNvPicPr>
@@ -11854,6 +12450,41 @@
                 </a:solidFill>
               </a:defRPr>
             </a:pPr>
+          </a:p>
+        </p:txBody>
+      </p:sp>
+      <p:sp>
+        <p:nvSpPr>
+          <p:cNvPr id="114" name="TextBox 113"/>
+          <p:cNvSpPr txBox="1"/>
+          <p:nvPr/>
+        </p:nvSpPr>
+        <p:spPr>
+          <a:xfrm>
+            <a:off x="731520" y="1097280"/>
+            <a:ext cx="7680960" cy="4572000"/>
+          </a:xfrm>
+          <a:prstGeom prst="rect">
+            <a:avLst/>
+          </a:prstGeom>
+          <a:noFill/>
+        </p:spPr>
+        <p:txBody>
+          <a:bodyPr wrap="square">
+            <a:spAutoFit/>
+          </a:bodyPr>
+          <a:lstStyle/>
+          <a:p>
+            <a:pPr>
+              <a:spcAft>
+                <a:spcPts val="1200"/>
+              </a:spcAft>
+              <a:defRPr b="1" sz="2000">
+                <a:solidFill>
+                  <a:srgbClr val="047857"/>
+                </a:solidFill>
+              </a:defRPr>
+            </a:pPr>
             <a:r>
               <a:t>System Architecture Diagram</a:t>
             </a:r>
@@ -12199,6 +12830,41 @@
       <p:sp>
         <p:nvSpPr>
           <p:cNvPr id="121" name="TextBox 120"/>
+          <p:cNvSpPr txBox="1"/>
+          <p:nvPr/>
+        </p:nvSpPr>
+        <p:spPr>
+          <a:xfrm>
+            <a:off x="731520" y="1097280"/>
+            <a:ext cx="7680960" cy="4572000"/>
+          </a:xfrm>
+          <a:prstGeom prst="rect">
+            <a:avLst/>
+          </a:prstGeom>
+          <a:noFill/>
+        </p:spPr>
+        <p:txBody>
+          <a:bodyPr wrap="square">
+            <a:spAutoFit/>
+          </a:bodyPr>
+          <a:lstStyle/>
+          <a:p>
+            <a:pPr>
+              <a:spcAft>
+                <a:spcPts val="1200"/>
+              </a:spcAft>
+              <a:defRPr b="1" sz="2000">
+                <a:solidFill>
+                  <a:srgbClr val="047857"/>
+                </a:solidFill>
+              </a:defRPr>
+            </a:pPr>
+          </a:p>
+        </p:txBody>
+      </p:sp>
+      <p:sp>
+        <p:nvSpPr>
+          <p:cNvPr id="122" name="TextBox 121"/>
           <p:cNvSpPr txBox="1"/>
           <p:nvPr/>
         </p:nvSpPr>

</xml_diff>

<commit_message>
chore: synchronize live public prototype URL in pitch deck and PDF
</commit_message>
<xml_diff>
--- a/docs/EcoLoop_AI_Pitch_Deck.pptx
+++ b/docs/EcoLoop_AI_Pitch_Deck.pptx
@@ -7454,6 +7454,41 @@
                 </a:solidFill>
               </a:defRPr>
             </a:pPr>
+          </a:p>
+        </p:txBody>
+      </p:sp>
+      <p:sp>
+        <p:nvSpPr>
+          <p:cNvPr id="131" name="TextBox 130"/>
+          <p:cNvSpPr txBox="1"/>
+          <p:nvPr/>
+        </p:nvSpPr>
+        <p:spPr>
+          <a:xfrm>
+            <a:off x="731520" y="1097280"/>
+            <a:ext cx="7680960" cy="4572000"/>
+          </a:xfrm>
+          <a:prstGeom prst="rect">
+            <a:avLst/>
+          </a:prstGeom>
+          <a:noFill/>
+        </p:spPr>
+        <p:txBody>
+          <a:bodyPr wrap="square">
+            <a:spAutoFit/>
+          </a:bodyPr>
+          <a:lstStyle/>
+          <a:p>
+            <a:pPr>
+              <a:spcAft>
+                <a:spcPts val="1200"/>
+              </a:spcAft>
+              <a:defRPr b="1" sz="2000">
+                <a:solidFill>
+                  <a:srgbClr val="047857"/>
+                </a:solidFill>
+              </a:defRPr>
+            </a:pPr>
             <a:r>
               <a:t>Estimated Implementation &amp; Operating Cost</a:t>
             </a:r>
@@ -7930,21 +7965,6 @@
                 </a:solidFill>
               </a:defRPr>
             </a:pPr>
-            <a:r>
-              <a:t>Snapshots of the Working Prototype</a:t>
-            </a:r>
-          </a:p>
-          <a:p>
-            <a:pPr>
-              <a:defRPr sz="1100">
-                <a:solidFill>
-                  <a:srgbClr val="64748B"/>
-                </a:solidFill>
-              </a:defRPr>
-            </a:pPr>
-            <a:r>
-              <a:t>Multimodal Gemini 2.5 Scanner • Malayalam Localization • Collector Portal • Auditable Impact Ledger</a:t>
-            </a:r>
           </a:p>
         </p:txBody>
       </p:sp>
@@ -8023,6 +8043,149 @@
       <p:pic>
         <p:nvPicPr>
           <p:cNvPr id="146" name="Picture 145" descr="image.png"/>
+          <p:cNvPicPr>
+            <a:picLocks noChangeAspect="1"/>
+          </p:cNvPicPr>
+          <p:nvPr/>
+        </p:nvPicPr>
+        <p:blipFill>
+          <a:blip r:embed="rId8"/>
+          <a:stretch>
+            <a:fillRect/>
+          </a:stretch>
+        </p:blipFill>
+        <p:spPr>
+          <a:xfrm>
+            <a:off x="4663440" y="3108960"/>
+            <a:ext cx="3840480" cy="1783080"/>
+          </a:xfrm>
+          <a:prstGeom prst="rect">
+            <a:avLst/>
+          </a:prstGeom>
+        </p:spPr>
+      </p:pic>
+      <p:sp>
+        <p:nvSpPr>
+          <p:cNvPr id="147" name="TextBox 146"/>
+          <p:cNvSpPr txBox="1"/>
+          <p:nvPr/>
+        </p:nvSpPr>
+        <p:spPr>
+          <a:xfrm>
+            <a:off x="548640" y="365760"/>
+            <a:ext cx="8046720" cy="731520"/>
+          </a:xfrm>
+          <a:prstGeom prst="rect">
+            <a:avLst/>
+          </a:prstGeom>
+          <a:noFill/>
+        </p:spPr>
+        <p:txBody>
+          <a:bodyPr wrap="square">
+            <a:spAutoFit/>
+          </a:bodyPr>
+          <a:lstStyle/>
+          <a:p>
+            <a:pPr>
+              <a:defRPr b="1" sz="2200">
+                <a:solidFill>
+                  <a:srgbClr val="047857"/>
+                </a:solidFill>
+              </a:defRPr>
+            </a:pPr>
+            <a:r>
+              <a:t>Snapshots of the Working Prototype</a:t>
+            </a:r>
+          </a:p>
+          <a:p>
+            <a:pPr>
+              <a:defRPr sz="1100">
+                <a:solidFill>
+                  <a:srgbClr val="64748B"/>
+                </a:solidFill>
+              </a:defRPr>
+            </a:pPr>
+            <a:r>
+              <a:t>Multimodal Gemini 2.5 Scanner • Malayalam Localization • Collector Portal • Auditable Impact Ledger</a:t>
+            </a:r>
+          </a:p>
+        </p:txBody>
+      </p:sp>
+      <p:pic>
+        <p:nvPicPr>
+          <p:cNvPr id="148" name="Picture 147" descr="image.png"/>
+          <p:cNvPicPr>
+            <a:picLocks noChangeAspect="1"/>
+          </p:cNvPicPr>
+          <p:nvPr/>
+        </p:nvPicPr>
+        <p:blipFill>
+          <a:blip r:embed="rId5"/>
+          <a:stretch>
+            <a:fillRect/>
+          </a:stretch>
+        </p:blipFill>
+        <p:spPr>
+          <a:xfrm>
+            <a:off x="548640" y="1188720"/>
+            <a:ext cx="3840480" cy="1783080"/>
+          </a:xfrm>
+          <a:prstGeom prst="rect">
+            <a:avLst/>
+          </a:prstGeom>
+        </p:spPr>
+      </p:pic>
+      <p:pic>
+        <p:nvPicPr>
+          <p:cNvPr id="149" name="Picture 148" descr="image.png"/>
+          <p:cNvPicPr>
+            <a:picLocks noChangeAspect="1"/>
+          </p:cNvPicPr>
+          <p:nvPr/>
+        </p:nvPicPr>
+        <p:blipFill>
+          <a:blip r:embed="rId6"/>
+          <a:stretch>
+            <a:fillRect/>
+          </a:stretch>
+        </p:blipFill>
+        <p:spPr>
+          <a:xfrm>
+            <a:off x="4663440" y="1188720"/>
+            <a:ext cx="3840480" cy="1783080"/>
+          </a:xfrm>
+          <a:prstGeom prst="rect">
+            <a:avLst/>
+          </a:prstGeom>
+        </p:spPr>
+      </p:pic>
+      <p:pic>
+        <p:nvPicPr>
+          <p:cNvPr id="150" name="Picture 149" descr="image.png"/>
+          <p:cNvPicPr>
+            <a:picLocks noChangeAspect="1"/>
+          </p:cNvPicPr>
+          <p:nvPr/>
+        </p:nvPicPr>
+        <p:blipFill>
+          <a:blip r:embed="rId7"/>
+          <a:stretch>
+            <a:fillRect/>
+          </a:stretch>
+        </p:blipFill>
+        <p:spPr>
+          <a:xfrm>
+            <a:off x="548640" y="3108960"/>
+            <a:ext cx="3840480" cy="1783080"/>
+          </a:xfrm>
+          <a:prstGeom prst="rect">
+            <a:avLst/>
+          </a:prstGeom>
+        </p:spPr>
+      </p:pic>
+      <p:pic>
+        <p:nvPicPr>
+          <p:cNvPr id="151" name="Picture 150" descr="image.png"/>
           <p:cNvPicPr>
             <a:picLocks noChangeAspect="1"/>
           </p:cNvPicPr>
@@ -8309,6 +8472,41 @@
                 </a:solidFill>
               </a:defRPr>
             </a:pPr>
+          </a:p>
+        </p:txBody>
+      </p:sp>
+      <p:sp>
+        <p:nvSpPr>
+          <p:cNvPr id="147" name="TextBox 146"/>
+          <p:cNvSpPr txBox="1"/>
+          <p:nvPr/>
+        </p:nvSpPr>
+        <p:spPr>
+          <a:xfrm>
+            <a:off x="731520" y="1097280"/>
+            <a:ext cx="7680960" cy="4572000"/>
+          </a:xfrm>
+          <a:prstGeom prst="rect">
+            <a:avLst/>
+          </a:prstGeom>
+          <a:noFill/>
+        </p:spPr>
+        <p:txBody>
+          <a:bodyPr wrap="square">
+            <a:spAutoFit/>
+          </a:bodyPr>
+          <a:lstStyle/>
+          <a:p>
+            <a:pPr>
+              <a:spcAft>
+                <a:spcPts val="1200"/>
+              </a:spcAft>
+              <a:defRPr b="1" sz="2000">
+                <a:solidFill>
+                  <a:srgbClr val="047857"/>
+                </a:solidFill>
+              </a:defRPr>
+            </a:pPr>
             <a:r>
               <a:t>Prototype Performance &amp; Quality Benchmarks</a:t>
             </a:r>
@@ -8695,6 +8893,41 @@
                 </a:solidFill>
               </a:defRPr>
             </a:pPr>
+          </a:p>
+        </p:txBody>
+      </p:sp>
+      <p:sp>
+        <p:nvSpPr>
+          <p:cNvPr id="155" name="TextBox 154"/>
+          <p:cNvSpPr txBox="1"/>
+          <p:nvPr/>
+        </p:nvSpPr>
+        <p:spPr>
+          <a:xfrm>
+            <a:off x="731520" y="1097280"/>
+            <a:ext cx="7680960" cy="4572000"/>
+          </a:xfrm>
+          <a:prstGeom prst="rect">
+            <a:avLst/>
+          </a:prstGeom>
+          <a:noFill/>
+        </p:spPr>
+        <p:txBody>
+          <a:bodyPr wrap="square">
+            <a:spAutoFit/>
+          </a:bodyPr>
+          <a:lstStyle/>
+          <a:p>
+            <a:pPr>
+              <a:spcAft>
+                <a:spcPts val="1200"/>
+              </a:spcAft>
+              <a:defRPr b="1" sz="2000">
+                <a:solidFill>
+                  <a:srgbClr val="047857"/>
+                </a:solidFill>
+              </a:defRPr>
+            </a:pPr>
             <a:r>
               <a:t>Future Development &amp; Commercial Roadmap</a:t>
             </a:r>
@@ -9058,6 +9291,41 @@
                 </a:solidFill>
               </a:defRPr>
             </a:pPr>
+          </a:p>
+        </p:txBody>
+      </p:sp>
+      <p:sp>
+        <p:nvSpPr>
+          <p:cNvPr id="163" name="TextBox 162"/>
+          <p:cNvSpPr txBox="1"/>
+          <p:nvPr/>
+        </p:nvSpPr>
+        <p:spPr>
+          <a:xfrm>
+            <a:off x="731520" y="914400"/>
+            <a:ext cx="7680960" cy="4572000"/>
+          </a:xfrm>
+          <a:prstGeom prst="rect">
+            <a:avLst/>
+          </a:prstGeom>
+          <a:noFill/>
+        </p:spPr>
+        <p:txBody>
+          <a:bodyPr wrap="square">
+            <a:spAutoFit/>
+          </a:bodyPr>
+          <a:lstStyle/>
+          <a:p>
+            <a:pPr>
+              <a:spcAft>
+                <a:spcPts val="1200"/>
+              </a:spcAft>
+              <a:defRPr b="1" sz="2000">
+                <a:solidFill>
+                  <a:srgbClr val="047857"/>
+                </a:solidFill>
+              </a:defRPr>
+            </a:pPr>
             <a:r>
               <a:t>Official Submission Links</a:t>
             </a:r>
@@ -9082,7 +9350,7 @@
                   <a:srgbClr val="1E293B"/>
                 </a:solidFill>
               </a:rPr>
-              <a:t>https://3901e40689d1c1.lhr.life (Live Public HTTPS Prototype — zero password/interstitials)</a:t>
+              <a:t>https://de73c714fd0228.lhr.life (Live Public HTTPS Prototype — zero password/interstitials)</a:t>
             </a:r>
           </a:p>
           <a:p>
@@ -9470,6 +9738,41 @@
                 </a:solidFill>
               </a:defRPr>
             </a:pPr>
+          </a:p>
+        </p:txBody>
+      </p:sp>
+      <p:sp>
+        <p:nvSpPr>
+          <p:cNvPr id="170" name="TextBox 169"/>
+          <p:cNvSpPr txBox="1"/>
+          <p:nvPr/>
+        </p:nvSpPr>
+        <p:spPr>
+          <a:xfrm>
+            <a:off x="731520" y="1097280"/>
+            <a:ext cx="7680960" cy="4572000"/>
+          </a:xfrm>
+          <a:prstGeom prst="rect">
+            <a:avLst/>
+          </a:prstGeom>
+          <a:noFill/>
+        </p:spPr>
+        <p:txBody>
+          <a:bodyPr wrap="square">
+            <a:spAutoFit/>
+          </a:bodyPr>
+          <a:lstStyle/>
+          <a:p>
+            <a:pPr>
+              <a:spcAft>
+                <a:spcPts val="1200"/>
+              </a:spcAft>
+              <a:defRPr b="1" sz="2000">
+                <a:solidFill>
+                  <a:srgbClr val="047857"/>
+                </a:solidFill>
+              </a:defRPr>
+            </a:pPr>
             <a:r>
               <a:t>Why EcoLoop AI Wins the AI Builder Cup</a:t>
             </a:r>
@@ -9750,6 +10053,41 @@
                 </a:solidFill>
               </a:defRPr>
             </a:pPr>
+          </a:p>
+        </p:txBody>
+      </p:sp>
+      <p:sp>
+        <p:nvSpPr>
+          <p:cNvPr id="176" name="TextBox 175"/>
+          <p:cNvSpPr txBox="1"/>
+          <p:nvPr/>
+        </p:nvSpPr>
+        <p:spPr>
+          <a:xfrm>
+            <a:off x="1371600" y="2011680"/>
+            <a:ext cx="6400800" cy="2743200"/>
+          </a:xfrm>
+          <a:prstGeom prst="rect">
+            <a:avLst/>
+          </a:prstGeom>
+          <a:noFill/>
+        </p:spPr>
+        <p:txBody>
+          <a:bodyPr wrap="square">
+            <a:spAutoFit/>
+          </a:bodyPr>
+          <a:lstStyle/>
+          <a:p>
+            <a:pPr>
+              <a:spcAft>
+                <a:spcPts val="1200"/>
+              </a:spcAft>
+              <a:defRPr b="1" sz="2000">
+                <a:solidFill>
+                  <a:srgbClr val="047857"/>
+                </a:solidFill>
+              </a:defRPr>
+            </a:pPr>
             <a:r>
               <a:t>EcoLoop AI — From Waste to Verified Value</a:t>
             </a:r>
@@ -10048,6 +10386,41 @@
       <p:sp>
         <p:nvSpPr>
           <p:cNvPr id="67" name="TextBox 66"/>
+          <p:cNvSpPr txBox="1"/>
+          <p:nvPr/>
+        </p:nvSpPr>
+        <p:spPr>
+          <a:xfrm>
+            <a:off x="731520" y="1097280"/>
+            <a:ext cx="7680960" cy="4572000"/>
+          </a:xfrm>
+          <a:prstGeom prst="rect">
+            <a:avLst/>
+          </a:prstGeom>
+          <a:noFill/>
+        </p:spPr>
+        <p:txBody>
+          <a:bodyPr wrap="square">
+            <a:spAutoFit/>
+          </a:bodyPr>
+          <a:lstStyle/>
+          <a:p>
+            <a:pPr>
+              <a:spcAft>
+                <a:spcPts val="1200"/>
+              </a:spcAft>
+              <a:defRPr b="1" sz="2000">
+                <a:solidFill>
+                  <a:srgbClr val="047857"/>
+                </a:solidFill>
+              </a:defRPr>
+            </a:pPr>
+          </a:p>
+        </p:txBody>
+      </p:sp>
+      <p:sp>
+        <p:nvSpPr>
+          <p:cNvPr id="68" name="TextBox 67"/>
           <p:cNvSpPr txBox="1"/>
           <p:nvPr/>
         </p:nvSpPr>
@@ -10413,6 +10786,41 @@
                 </a:solidFill>
               </a:defRPr>
             </a:pPr>
+          </a:p>
+        </p:txBody>
+      </p:sp>
+      <p:sp>
+        <p:nvSpPr>
+          <p:cNvPr id="75" name="TextBox 74"/>
+          <p:cNvSpPr txBox="1"/>
+          <p:nvPr/>
+        </p:nvSpPr>
+        <p:spPr>
+          <a:xfrm>
+            <a:off x="731520" y="1097280"/>
+            <a:ext cx="7680960" cy="4572000"/>
+          </a:xfrm>
+          <a:prstGeom prst="rect">
+            <a:avLst/>
+          </a:prstGeom>
+          <a:noFill/>
+        </p:spPr>
+        <p:txBody>
+          <a:bodyPr wrap="square">
+            <a:spAutoFit/>
+          </a:bodyPr>
+          <a:lstStyle/>
+          <a:p>
+            <a:pPr>
+              <a:spcAft>
+                <a:spcPts val="1200"/>
+              </a:spcAft>
+              <a:defRPr b="1" sz="2000">
+                <a:solidFill>
+                  <a:srgbClr val="047857"/>
+                </a:solidFill>
+              </a:defRPr>
+            </a:pPr>
             <a:r>
               <a:t>Brief About the Idea — EcoLoop AI</a:t>
             </a:r>
@@ -10753,6 +11161,41 @@
                 </a:solidFill>
               </a:defRPr>
             </a:pPr>
+          </a:p>
+        </p:txBody>
+      </p:sp>
+      <p:sp>
+        <p:nvSpPr>
+          <p:cNvPr id="83" name="TextBox 82"/>
+          <p:cNvSpPr txBox="1"/>
+          <p:nvPr/>
+        </p:nvSpPr>
+        <p:spPr>
+          <a:xfrm>
+            <a:off x="731520" y="1097280"/>
+            <a:ext cx="7680960" cy="4572000"/>
+          </a:xfrm>
+          <a:prstGeom prst="rect">
+            <a:avLst/>
+          </a:prstGeom>
+          <a:noFill/>
+        </p:spPr>
+        <p:txBody>
+          <a:bodyPr wrap="square">
+            <a:spAutoFit/>
+          </a:bodyPr>
+          <a:lstStyle/>
+          <a:p>
+            <a:pPr>
+              <a:spcAft>
+                <a:spcPts val="1200"/>
+              </a:spcAft>
+              <a:defRPr b="1" sz="2000">
+                <a:solidFill>
+                  <a:srgbClr val="047857"/>
+                </a:solidFill>
+              </a:defRPr>
+            </a:pPr>
             <a:r>
               <a:t>Opportunities &amp; Unique Selling Proposition (USP)</a:t>
             </a:r>
@@ -11139,6 +11582,41 @@
                 </a:solidFill>
               </a:defRPr>
             </a:pPr>
+          </a:p>
+        </p:txBody>
+      </p:sp>
+      <p:sp>
+        <p:nvSpPr>
+          <p:cNvPr id="91" name="TextBox 90"/>
+          <p:cNvSpPr txBox="1"/>
+          <p:nvPr/>
+        </p:nvSpPr>
+        <p:spPr>
+          <a:xfrm>
+            <a:off x="731520" y="1097280"/>
+            <a:ext cx="7680960" cy="4572000"/>
+          </a:xfrm>
+          <a:prstGeom prst="rect">
+            <a:avLst/>
+          </a:prstGeom>
+          <a:noFill/>
+        </p:spPr>
+        <p:txBody>
+          <a:bodyPr wrap="square">
+            <a:spAutoFit/>
+          </a:bodyPr>
+          <a:lstStyle/>
+          <a:p>
+            <a:pPr>
+              <a:spcAft>
+                <a:spcPts val="1200"/>
+              </a:spcAft>
+              <a:defRPr b="1" sz="2000">
+                <a:solidFill>
+                  <a:srgbClr val="047857"/>
+                </a:solidFill>
+              </a:defRPr>
+            </a:pPr>
             <a:r>
               <a:t>Key Features Offered by EcoLoop AI</a:t>
             </a:r>
@@ -11571,6 +12049,41 @@
                 </a:solidFill>
               </a:defRPr>
             </a:pPr>
+          </a:p>
+        </p:txBody>
+      </p:sp>
+      <p:sp>
+        <p:nvSpPr>
+          <p:cNvPr id="99" name="TextBox 98"/>
+          <p:cNvSpPr txBox="1"/>
+          <p:nvPr/>
+        </p:nvSpPr>
+        <p:spPr>
+          <a:xfrm>
+            <a:off x="731520" y="1097280"/>
+            <a:ext cx="7680960" cy="4572000"/>
+          </a:xfrm>
+          <a:prstGeom prst="rect">
+            <a:avLst/>
+          </a:prstGeom>
+          <a:noFill/>
+        </p:spPr>
+        <p:txBody>
+          <a:bodyPr wrap="square">
+            <a:spAutoFit/>
+          </a:bodyPr>
+          <a:lstStyle/>
+          <a:p>
+            <a:pPr>
+              <a:spcAft>
+                <a:spcPts val="1200"/>
+              </a:spcAft>
+              <a:defRPr b="1" sz="2000">
+                <a:solidFill>
+                  <a:srgbClr val="047857"/>
+                </a:solidFill>
+              </a:defRPr>
+            </a:pPr>
             <a:r>
               <a:t>Process Flow &amp; Use-Case Diagram</a:t>
             </a:r>
@@ -12051,124 +12564,6 @@
                 </a:solidFill>
               </a:defRPr>
             </a:pPr>
-            <a:r>
-              <a:t>UI Wireframes &amp; Component Hierarchy</a:t>
-            </a:r>
-          </a:p>
-          <a:p>
-            <a:pPr>
-              <a:spcAft>
-                <a:spcPts val="600"/>
-              </a:spcAft>
-            </a:pPr>
-            <a:r>
-              <a:rPr b="1" sz="1300">
-                <a:solidFill>
-                  <a:srgbClr val="1E293B"/>
-                </a:solidFill>
-              </a:rPr>
-              <a:t>• View 1 - AI Waste Scanner: </a:t>
-            </a:r>
-            <a:r>
-              <a:rPr sz="1300">
-                <a:solidFill>
-                  <a:srgbClr val="1E293B"/>
-                </a:solidFill>
-              </a:rPr>
-              <a:t>Hero banner, sample selector (Milma pouch, PET bottle, box, battery), real-time reasoning ticker.</a:t>
-            </a:r>
-          </a:p>
-          <a:p>
-            <a:pPr>
-              <a:spcAft>
-                <a:spcPts val="600"/>
-              </a:spcAft>
-            </a:pPr>
-            <a:r>
-              <a:rPr b="1" sz="1300">
-                <a:solidFill>
-                  <a:srgbClr val="1E293B"/>
-                </a:solidFill>
-              </a:rPr>
-              <a:t>• View 2 - Dynamic Guidance Card: </a:t>
-            </a:r>
-            <a:r>
-              <a:rPr sz="1300">
-                <a:solidFill>
-                  <a:srgbClr val="1E293B"/>
-                </a:solidFill>
-              </a:rPr>
-              <a:t>Certainty score badge, contamination alert, Suchitwa Mission cleaning/drying steps.</a:t>
-            </a:r>
-          </a:p>
-          <a:p>
-            <a:pPr>
-              <a:spcAft>
-                <a:spcPts val="600"/>
-              </a:spcAft>
-            </a:pPr>
-            <a:r>
-              <a:rPr b="1" sz="1300">
-                <a:solidFill>
-                  <a:srgbClr val="1E293B"/>
-                </a:solidFill>
-              </a:rPr>
-              <a:t>• View 3 - Kerala Recovery Hubs: </a:t>
-            </a:r>
-            <a:r>
-              <a:rPr sz="1300">
-                <a:solidFill>
-                  <a:srgbClr val="1E293B"/>
-                </a:solidFill>
-              </a:rPr>
-              <a:t>District and material category filters, collection calendars, facility addresses.</a:t>
-            </a:r>
-          </a:p>
-          <a:p>
-            <a:pPr>
-              <a:spcAft>
-                <a:spcPts val="600"/>
-              </a:spcAft>
-            </a:pPr>
-            <a:r>
-              <a:rPr b="1" sz="1300">
-                <a:solidFill>
-                  <a:srgbClr val="1E293B"/>
-                </a:solidFill>
-              </a:rPr>
-              <a:t>• View 4 - Collector Portal: </a:t>
-            </a:r>
-            <a:r>
-              <a:rPr sz="1300">
-                <a:solidFill>
-                  <a:srgbClr val="1E293B"/>
-                </a:solidFill>
-              </a:rPr>
-              <a:t>PIN-gated queue of pending pickups, certified scale weight entry, tamper-evident receipts.</a:t>
-            </a:r>
-          </a:p>
-          <a:p>
-            <a:pPr>
-              <a:spcAft>
-                <a:spcPts val="600"/>
-              </a:spcAft>
-            </a:pPr>
-            <a:r>
-              <a:rPr b="1" sz="1300">
-                <a:solidFill>
-                  <a:srgbClr val="1E293B"/>
-                </a:solidFill>
-              </a:rPr>
-              <a:t>• View 5 - Impact Ledger: </a:t>
-            </a:r>
-            <a:r>
-              <a:rPr sz="1300">
-                <a:solidFill>
-                  <a:srgbClr val="1E293B"/>
-                </a:solidFill>
-              </a:rPr>
-              <a:t>Verified landfill kg diverted, avoided CO2e, and live auditable handover feed.</a:t>
-            </a:r>
           </a:p>
         </p:txBody>
       </p:sp>
@@ -12199,6 +12594,207 @@
       <p:pic>
         <p:nvPicPr>
           <p:cNvPr id="110" name="Picture 109" descr="image.png"/>
+          <p:cNvPicPr>
+            <a:picLocks noChangeAspect="1"/>
+          </p:cNvPicPr>
+          <p:nvPr/>
+        </p:nvPicPr>
+        <p:blipFill>
+          <a:blip r:embed="rId6"/>
+          <a:stretch>
+            <a:fillRect/>
+          </a:stretch>
+        </p:blipFill>
+        <p:spPr>
+          <a:xfrm>
+            <a:off x="4754880" y="2926080"/>
+            <a:ext cx="3931920" cy="1828800"/>
+          </a:xfrm>
+          <a:prstGeom prst="rect">
+            <a:avLst/>
+          </a:prstGeom>
+        </p:spPr>
+      </p:pic>
+      <p:sp>
+        <p:nvSpPr>
+          <p:cNvPr id="111" name="TextBox 110"/>
+          <p:cNvSpPr txBox="1"/>
+          <p:nvPr/>
+        </p:nvSpPr>
+        <p:spPr>
+          <a:xfrm>
+            <a:off x="548640" y="914400"/>
+            <a:ext cx="4023360" cy="4023360"/>
+          </a:xfrm>
+          <a:prstGeom prst="rect">
+            <a:avLst/>
+          </a:prstGeom>
+          <a:noFill/>
+        </p:spPr>
+        <p:txBody>
+          <a:bodyPr wrap="square">
+            <a:spAutoFit/>
+          </a:bodyPr>
+          <a:lstStyle/>
+          <a:p>
+            <a:pPr>
+              <a:spcAft>
+                <a:spcPts val="1200"/>
+              </a:spcAft>
+              <a:defRPr b="1" sz="2000">
+                <a:solidFill>
+                  <a:srgbClr val="047857"/>
+                </a:solidFill>
+              </a:defRPr>
+            </a:pPr>
+            <a:r>
+              <a:t>UI Wireframes &amp; Component Hierarchy</a:t>
+            </a:r>
+          </a:p>
+          <a:p>
+            <a:pPr>
+              <a:spcAft>
+                <a:spcPts val="600"/>
+              </a:spcAft>
+            </a:pPr>
+            <a:r>
+              <a:rPr b="1" sz="1300">
+                <a:solidFill>
+                  <a:srgbClr val="1E293B"/>
+                </a:solidFill>
+              </a:rPr>
+              <a:t>• View 1 - AI Waste Scanner: </a:t>
+            </a:r>
+            <a:r>
+              <a:rPr sz="1300">
+                <a:solidFill>
+                  <a:srgbClr val="1E293B"/>
+                </a:solidFill>
+              </a:rPr>
+              <a:t>Hero banner, sample selector (Milma pouch, PET bottle, box, battery), real-time reasoning ticker.</a:t>
+            </a:r>
+          </a:p>
+          <a:p>
+            <a:pPr>
+              <a:spcAft>
+                <a:spcPts val="600"/>
+              </a:spcAft>
+            </a:pPr>
+            <a:r>
+              <a:rPr b="1" sz="1300">
+                <a:solidFill>
+                  <a:srgbClr val="1E293B"/>
+                </a:solidFill>
+              </a:rPr>
+              <a:t>• View 2 - Dynamic Guidance Card: </a:t>
+            </a:r>
+            <a:r>
+              <a:rPr sz="1300">
+                <a:solidFill>
+                  <a:srgbClr val="1E293B"/>
+                </a:solidFill>
+              </a:rPr>
+              <a:t>Certainty score badge, contamination alert, Suchitwa Mission cleaning/drying steps.</a:t>
+            </a:r>
+          </a:p>
+          <a:p>
+            <a:pPr>
+              <a:spcAft>
+                <a:spcPts val="600"/>
+              </a:spcAft>
+            </a:pPr>
+            <a:r>
+              <a:rPr b="1" sz="1300">
+                <a:solidFill>
+                  <a:srgbClr val="1E293B"/>
+                </a:solidFill>
+              </a:rPr>
+              <a:t>• View 3 - Kerala Recovery Hubs: </a:t>
+            </a:r>
+            <a:r>
+              <a:rPr sz="1300">
+                <a:solidFill>
+                  <a:srgbClr val="1E293B"/>
+                </a:solidFill>
+              </a:rPr>
+              <a:t>District and material category filters, collection calendars, facility addresses.</a:t>
+            </a:r>
+          </a:p>
+          <a:p>
+            <a:pPr>
+              <a:spcAft>
+                <a:spcPts val="600"/>
+              </a:spcAft>
+            </a:pPr>
+            <a:r>
+              <a:rPr b="1" sz="1300">
+                <a:solidFill>
+                  <a:srgbClr val="1E293B"/>
+                </a:solidFill>
+              </a:rPr>
+              <a:t>• View 4 - Collector Portal: </a:t>
+            </a:r>
+            <a:r>
+              <a:rPr sz="1300">
+                <a:solidFill>
+                  <a:srgbClr val="1E293B"/>
+                </a:solidFill>
+              </a:rPr>
+              <a:t>PIN-gated queue of pending pickups, certified scale weight entry, tamper-evident receipts.</a:t>
+            </a:r>
+          </a:p>
+          <a:p>
+            <a:pPr>
+              <a:spcAft>
+                <a:spcPts val="600"/>
+              </a:spcAft>
+            </a:pPr>
+            <a:r>
+              <a:rPr b="1" sz="1300">
+                <a:solidFill>
+                  <a:srgbClr val="1E293B"/>
+                </a:solidFill>
+              </a:rPr>
+              <a:t>• View 5 - Impact Ledger: </a:t>
+            </a:r>
+            <a:r>
+              <a:rPr sz="1300">
+                <a:solidFill>
+                  <a:srgbClr val="1E293B"/>
+                </a:solidFill>
+              </a:rPr>
+              <a:t>Verified landfill kg diverted, avoided CO2e, and live auditable handover feed.</a:t>
+            </a:r>
+          </a:p>
+        </p:txBody>
+      </p:sp>
+      <p:pic>
+        <p:nvPicPr>
+          <p:cNvPr id="112" name="Picture 111" descr="image.png"/>
+          <p:cNvPicPr>
+            <a:picLocks noChangeAspect="1"/>
+          </p:cNvPicPr>
+          <p:nvPr/>
+        </p:nvPicPr>
+        <p:blipFill>
+          <a:blip r:embed="rId5"/>
+          <a:stretch>
+            <a:fillRect/>
+          </a:stretch>
+        </p:blipFill>
+        <p:spPr>
+          <a:xfrm>
+            <a:off x="4754880" y="914400"/>
+            <a:ext cx="3931920" cy="1828800"/>
+          </a:xfrm>
+          <a:prstGeom prst="rect">
+            <a:avLst/>
+          </a:prstGeom>
+        </p:spPr>
+      </p:pic>
+      <p:pic>
+        <p:nvPicPr>
+          <p:cNvPr id="113" name="Picture 112" descr="image.png"/>
           <p:cNvPicPr>
             <a:picLocks noChangeAspect="1"/>
           </p:cNvPicPr>
@@ -12485,6 +13081,41 @@
                 </a:solidFill>
               </a:defRPr>
             </a:pPr>
+          </a:p>
+        </p:txBody>
+      </p:sp>
+      <p:sp>
+        <p:nvSpPr>
+          <p:cNvPr id="115" name="TextBox 114"/>
+          <p:cNvSpPr txBox="1"/>
+          <p:nvPr/>
+        </p:nvSpPr>
+        <p:spPr>
+          <a:xfrm>
+            <a:off x="731520" y="1097280"/>
+            <a:ext cx="7680960" cy="4572000"/>
+          </a:xfrm>
+          <a:prstGeom prst="rect">
+            <a:avLst/>
+          </a:prstGeom>
+          <a:noFill/>
+        </p:spPr>
+        <p:txBody>
+          <a:bodyPr wrap="square">
+            <a:spAutoFit/>
+          </a:bodyPr>
+          <a:lstStyle/>
+          <a:p>
+            <a:pPr>
+              <a:spcAft>
+                <a:spcPts val="1200"/>
+              </a:spcAft>
+              <a:defRPr b="1" sz="2000">
+                <a:solidFill>
+                  <a:srgbClr val="047857"/>
+                </a:solidFill>
+              </a:defRPr>
+            </a:pPr>
             <a:r>
               <a:t>System Architecture Diagram</a:t>
             </a:r>
@@ -12865,6 +13496,41 @@
       <p:sp>
         <p:nvSpPr>
           <p:cNvPr id="122" name="TextBox 121"/>
+          <p:cNvSpPr txBox="1"/>
+          <p:nvPr/>
+        </p:nvSpPr>
+        <p:spPr>
+          <a:xfrm>
+            <a:off x="731520" y="1097280"/>
+            <a:ext cx="7680960" cy="4572000"/>
+          </a:xfrm>
+          <a:prstGeom prst="rect">
+            <a:avLst/>
+          </a:prstGeom>
+          <a:noFill/>
+        </p:spPr>
+        <p:txBody>
+          <a:bodyPr wrap="square">
+            <a:spAutoFit/>
+          </a:bodyPr>
+          <a:lstStyle/>
+          <a:p>
+            <a:pPr>
+              <a:spcAft>
+                <a:spcPts val="1200"/>
+              </a:spcAft>
+              <a:defRPr b="1" sz="2000">
+                <a:solidFill>
+                  <a:srgbClr val="047857"/>
+                </a:solidFill>
+              </a:defRPr>
+            </a:pPr>
+          </a:p>
+        </p:txBody>
+      </p:sp>
+      <p:sp>
+        <p:nvSpPr>
+          <p:cNvPr id="123" name="TextBox 122"/>
           <p:cNvSpPr txBox="1"/>
           <p:nvPr/>
         </p:nvSpPr>

</xml_diff>

<commit_message>
chore: synchronize official GitHub repository URL to muraliktg99/ecoloop-ai-hackathon in pitch deck
</commit_message>
<xml_diff>
--- a/docs/EcoLoop_AI_Pitch_Deck.pptx
+++ b/docs/EcoLoop_AI_Pitch_Deck.pptx
@@ -7489,6 +7489,41 @@
                 </a:solidFill>
               </a:defRPr>
             </a:pPr>
+          </a:p>
+        </p:txBody>
+      </p:sp>
+      <p:sp>
+        <p:nvSpPr>
+          <p:cNvPr id="132" name="TextBox 131"/>
+          <p:cNvSpPr txBox="1"/>
+          <p:nvPr/>
+        </p:nvSpPr>
+        <p:spPr>
+          <a:xfrm>
+            <a:off x="731520" y="1097280"/>
+            <a:ext cx="7680960" cy="4572000"/>
+          </a:xfrm>
+          <a:prstGeom prst="rect">
+            <a:avLst/>
+          </a:prstGeom>
+          <a:noFill/>
+        </p:spPr>
+        <p:txBody>
+          <a:bodyPr wrap="square">
+            <a:spAutoFit/>
+          </a:bodyPr>
+          <a:lstStyle/>
+          <a:p>
+            <a:pPr>
+              <a:spcAft>
+                <a:spcPts val="1200"/>
+              </a:spcAft>
+              <a:defRPr b="1" sz="2000">
+                <a:solidFill>
+                  <a:srgbClr val="047857"/>
+                </a:solidFill>
+              </a:defRPr>
+            </a:pPr>
             <a:r>
               <a:t>Estimated Implementation &amp; Operating Cost</a:t>
             </a:r>
@@ -8093,21 +8128,6 @@
                 </a:solidFill>
               </a:defRPr>
             </a:pPr>
-            <a:r>
-              <a:t>Snapshots of the Working Prototype</a:t>
-            </a:r>
-          </a:p>
-          <a:p>
-            <a:pPr>
-              <a:defRPr sz="1100">
-                <a:solidFill>
-                  <a:srgbClr val="64748B"/>
-                </a:solidFill>
-              </a:defRPr>
-            </a:pPr>
-            <a:r>
-              <a:t>Multimodal Gemini 2.5 Scanner • Malayalam Localization • Collector Portal • Auditable Impact Ledger</a:t>
-            </a:r>
           </a:p>
         </p:txBody>
       </p:sp>
@@ -8186,6 +8206,149 @@
       <p:pic>
         <p:nvPicPr>
           <p:cNvPr id="151" name="Picture 150" descr="image.png"/>
+          <p:cNvPicPr>
+            <a:picLocks noChangeAspect="1"/>
+          </p:cNvPicPr>
+          <p:nvPr/>
+        </p:nvPicPr>
+        <p:blipFill>
+          <a:blip r:embed="rId8"/>
+          <a:stretch>
+            <a:fillRect/>
+          </a:stretch>
+        </p:blipFill>
+        <p:spPr>
+          <a:xfrm>
+            <a:off x="4663440" y="3108960"/>
+            <a:ext cx="3840480" cy="1783080"/>
+          </a:xfrm>
+          <a:prstGeom prst="rect">
+            <a:avLst/>
+          </a:prstGeom>
+        </p:spPr>
+      </p:pic>
+      <p:sp>
+        <p:nvSpPr>
+          <p:cNvPr id="152" name="TextBox 151"/>
+          <p:cNvSpPr txBox="1"/>
+          <p:nvPr/>
+        </p:nvSpPr>
+        <p:spPr>
+          <a:xfrm>
+            <a:off x="548640" y="365760"/>
+            <a:ext cx="8046720" cy="731520"/>
+          </a:xfrm>
+          <a:prstGeom prst="rect">
+            <a:avLst/>
+          </a:prstGeom>
+          <a:noFill/>
+        </p:spPr>
+        <p:txBody>
+          <a:bodyPr wrap="square">
+            <a:spAutoFit/>
+          </a:bodyPr>
+          <a:lstStyle/>
+          <a:p>
+            <a:pPr>
+              <a:defRPr b="1" sz="2200">
+                <a:solidFill>
+                  <a:srgbClr val="047857"/>
+                </a:solidFill>
+              </a:defRPr>
+            </a:pPr>
+            <a:r>
+              <a:t>Snapshots of the Working Prototype</a:t>
+            </a:r>
+          </a:p>
+          <a:p>
+            <a:pPr>
+              <a:defRPr sz="1100">
+                <a:solidFill>
+                  <a:srgbClr val="64748B"/>
+                </a:solidFill>
+              </a:defRPr>
+            </a:pPr>
+            <a:r>
+              <a:t>Multimodal Gemini 2.5 Scanner • Malayalam Localization • Collector Portal • Auditable Impact Ledger</a:t>
+            </a:r>
+          </a:p>
+        </p:txBody>
+      </p:sp>
+      <p:pic>
+        <p:nvPicPr>
+          <p:cNvPr id="153" name="Picture 152" descr="image.png"/>
+          <p:cNvPicPr>
+            <a:picLocks noChangeAspect="1"/>
+          </p:cNvPicPr>
+          <p:nvPr/>
+        </p:nvPicPr>
+        <p:blipFill>
+          <a:blip r:embed="rId5"/>
+          <a:stretch>
+            <a:fillRect/>
+          </a:stretch>
+        </p:blipFill>
+        <p:spPr>
+          <a:xfrm>
+            <a:off x="548640" y="1188720"/>
+            <a:ext cx="3840480" cy="1783080"/>
+          </a:xfrm>
+          <a:prstGeom prst="rect">
+            <a:avLst/>
+          </a:prstGeom>
+        </p:spPr>
+      </p:pic>
+      <p:pic>
+        <p:nvPicPr>
+          <p:cNvPr id="154" name="Picture 153" descr="image.png"/>
+          <p:cNvPicPr>
+            <a:picLocks noChangeAspect="1"/>
+          </p:cNvPicPr>
+          <p:nvPr/>
+        </p:nvPicPr>
+        <p:blipFill>
+          <a:blip r:embed="rId6"/>
+          <a:stretch>
+            <a:fillRect/>
+          </a:stretch>
+        </p:blipFill>
+        <p:spPr>
+          <a:xfrm>
+            <a:off x="4663440" y="1188720"/>
+            <a:ext cx="3840480" cy="1783080"/>
+          </a:xfrm>
+          <a:prstGeom prst="rect">
+            <a:avLst/>
+          </a:prstGeom>
+        </p:spPr>
+      </p:pic>
+      <p:pic>
+        <p:nvPicPr>
+          <p:cNvPr id="155" name="Picture 154" descr="image.png"/>
+          <p:cNvPicPr>
+            <a:picLocks noChangeAspect="1"/>
+          </p:cNvPicPr>
+          <p:nvPr/>
+        </p:nvPicPr>
+        <p:blipFill>
+          <a:blip r:embed="rId7"/>
+          <a:stretch>
+            <a:fillRect/>
+          </a:stretch>
+        </p:blipFill>
+        <p:spPr>
+          <a:xfrm>
+            <a:off x="548640" y="3108960"/>
+            <a:ext cx="3840480" cy="1783080"/>
+          </a:xfrm>
+          <a:prstGeom prst="rect">
+            <a:avLst/>
+          </a:prstGeom>
+        </p:spPr>
+      </p:pic>
+      <p:pic>
+        <p:nvPicPr>
+          <p:cNvPr id="156" name="Picture 155" descr="image.png"/>
           <p:cNvPicPr>
             <a:picLocks noChangeAspect="1"/>
           </p:cNvPicPr>
@@ -8507,6 +8670,41 @@
                 </a:solidFill>
               </a:defRPr>
             </a:pPr>
+          </a:p>
+        </p:txBody>
+      </p:sp>
+      <p:sp>
+        <p:nvSpPr>
+          <p:cNvPr id="148" name="TextBox 147"/>
+          <p:cNvSpPr txBox="1"/>
+          <p:nvPr/>
+        </p:nvSpPr>
+        <p:spPr>
+          <a:xfrm>
+            <a:off x="731520" y="1097280"/>
+            <a:ext cx="7680960" cy="4572000"/>
+          </a:xfrm>
+          <a:prstGeom prst="rect">
+            <a:avLst/>
+          </a:prstGeom>
+          <a:noFill/>
+        </p:spPr>
+        <p:txBody>
+          <a:bodyPr wrap="square">
+            <a:spAutoFit/>
+          </a:bodyPr>
+          <a:lstStyle/>
+          <a:p>
+            <a:pPr>
+              <a:spcAft>
+                <a:spcPts val="1200"/>
+              </a:spcAft>
+              <a:defRPr b="1" sz="2000">
+                <a:solidFill>
+                  <a:srgbClr val="047857"/>
+                </a:solidFill>
+              </a:defRPr>
+            </a:pPr>
             <a:r>
               <a:t>Prototype Performance &amp; Quality Benchmarks</a:t>
             </a:r>
@@ -8928,6 +9126,41 @@
                 </a:solidFill>
               </a:defRPr>
             </a:pPr>
+          </a:p>
+        </p:txBody>
+      </p:sp>
+      <p:sp>
+        <p:nvSpPr>
+          <p:cNvPr id="156" name="TextBox 155"/>
+          <p:cNvSpPr txBox="1"/>
+          <p:nvPr/>
+        </p:nvSpPr>
+        <p:spPr>
+          <a:xfrm>
+            <a:off x="731520" y="1097280"/>
+            <a:ext cx="7680960" cy="4572000"/>
+          </a:xfrm>
+          <a:prstGeom prst="rect">
+            <a:avLst/>
+          </a:prstGeom>
+          <a:noFill/>
+        </p:spPr>
+        <p:txBody>
+          <a:bodyPr wrap="square">
+            <a:spAutoFit/>
+          </a:bodyPr>
+          <a:lstStyle/>
+          <a:p>
+            <a:pPr>
+              <a:spcAft>
+                <a:spcPts val="1200"/>
+              </a:spcAft>
+              <a:defRPr b="1" sz="2000">
+                <a:solidFill>
+                  <a:srgbClr val="047857"/>
+                </a:solidFill>
+              </a:defRPr>
+            </a:pPr>
             <a:r>
               <a:t>Future Development &amp; Commercial Roadmap</a:t>
             </a:r>
@@ -9326,6 +9559,41 @@
                 </a:solidFill>
               </a:defRPr>
             </a:pPr>
+          </a:p>
+        </p:txBody>
+      </p:sp>
+      <p:sp>
+        <p:nvSpPr>
+          <p:cNvPr id="164" name="TextBox 163"/>
+          <p:cNvSpPr txBox="1"/>
+          <p:nvPr/>
+        </p:nvSpPr>
+        <p:spPr>
+          <a:xfrm>
+            <a:off x="731520" y="914400"/>
+            <a:ext cx="7680960" cy="4572000"/>
+          </a:xfrm>
+          <a:prstGeom prst="rect">
+            <a:avLst/>
+          </a:prstGeom>
+          <a:noFill/>
+        </p:spPr>
+        <p:txBody>
+          <a:bodyPr wrap="square">
+            <a:spAutoFit/>
+          </a:bodyPr>
+          <a:lstStyle/>
+          <a:p>
+            <a:pPr>
+              <a:spcAft>
+                <a:spcPts val="1200"/>
+              </a:spcAft>
+              <a:defRPr b="1" sz="2000">
+                <a:solidFill>
+                  <a:srgbClr val="047857"/>
+                </a:solidFill>
+              </a:defRPr>
+            </a:pPr>
             <a:r>
               <a:t>Official Submission Links</a:t>
             </a:r>
@@ -9396,7 +9664,7 @@
                   <a:srgbClr val="1E293B"/>
                 </a:solidFill>
               </a:rPr>
-              <a:t>https://github.com/krishnan/ecoloop-ai-hackathon (Contains source code, Vitest tests, Dockerfile, and docs)</a:t>
+              <a:t>https://github.com/muraliktg99/ecoloop-ai-hackathon (Contains source code, Vitest tests, Dockerfile, and docs)</a:t>
             </a:r>
           </a:p>
           <a:p>
@@ -9773,6 +10041,41 @@
                 </a:solidFill>
               </a:defRPr>
             </a:pPr>
+          </a:p>
+        </p:txBody>
+      </p:sp>
+      <p:sp>
+        <p:nvSpPr>
+          <p:cNvPr id="171" name="TextBox 170"/>
+          <p:cNvSpPr txBox="1"/>
+          <p:nvPr/>
+        </p:nvSpPr>
+        <p:spPr>
+          <a:xfrm>
+            <a:off x="731520" y="1097280"/>
+            <a:ext cx="7680960" cy="4572000"/>
+          </a:xfrm>
+          <a:prstGeom prst="rect">
+            <a:avLst/>
+          </a:prstGeom>
+          <a:noFill/>
+        </p:spPr>
+        <p:txBody>
+          <a:bodyPr wrap="square">
+            <a:spAutoFit/>
+          </a:bodyPr>
+          <a:lstStyle/>
+          <a:p>
+            <a:pPr>
+              <a:spcAft>
+                <a:spcPts val="1200"/>
+              </a:spcAft>
+              <a:defRPr b="1" sz="2000">
+                <a:solidFill>
+                  <a:srgbClr val="047857"/>
+                </a:solidFill>
+              </a:defRPr>
+            </a:pPr>
             <a:r>
               <a:t>Why EcoLoop AI Wins the AI Builder Cup</a:t>
             </a:r>
@@ -10088,6 +10391,41 @@
                 </a:solidFill>
               </a:defRPr>
             </a:pPr>
+          </a:p>
+        </p:txBody>
+      </p:sp>
+      <p:sp>
+        <p:nvSpPr>
+          <p:cNvPr id="177" name="TextBox 176"/>
+          <p:cNvSpPr txBox="1"/>
+          <p:nvPr/>
+        </p:nvSpPr>
+        <p:spPr>
+          <a:xfrm>
+            <a:off x="1371600" y="2011680"/>
+            <a:ext cx="6400800" cy="2743200"/>
+          </a:xfrm>
+          <a:prstGeom prst="rect">
+            <a:avLst/>
+          </a:prstGeom>
+          <a:noFill/>
+        </p:spPr>
+        <p:txBody>
+          <a:bodyPr wrap="square">
+            <a:spAutoFit/>
+          </a:bodyPr>
+          <a:lstStyle/>
+          <a:p>
+            <a:pPr>
+              <a:spcAft>
+                <a:spcPts val="1200"/>
+              </a:spcAft>
+              <a:defRPr b="1" sz="2000">
+                <a:solidFill>
+                  <a:srgbClr val="047857"/>
+                </a:solidFill>
+              </a:defRPr>
+            </a:pPr>
             <a:r>
               <a:t>EcoLoop AI — From Waste to Verified Value</a:t>
             </a:r>
@@ -10450,6 +10788,41 @@
                 </a:solidFill>
               </a:defRPr>
             </a:pPr>
+          </a:p>
+        </p:txBody>
+      </p:sp>
+      <p:sp>
+        <p:nvSpPr>
+          <p:cNvPr id="69" name="TextBox 68"/>
+          <p:cNvSpPr txBox="1"/>
+          <p:nvPr/>
+        </p:nvSpPr>
+        <p:spPr>
+          <a:xfrm>
+            <a:off x="731520" y="1097280"/>
+            <a:ext cx="7680960" cy="4572000"/>
+          </a:xfrm>
+          <a:prstGeom prst="rect">
+            <a:avLst/>
+          </a:prstGeom>
+          <a:noFill/>
+        </p:spPr>
+        <p:txBody>
+          <a:bodyPr wrap="square">
+            <a:spAutoFit/>
+          </a:bodyPr>
+          <a:lstStyle/>
+          <a:p>
+            <a:pPr>
+              <a:spcAft>
+                <a:spcPts val="1200"/>
+              </a:spcAft>
+              <a:defRPr b="1" sz="2000">
+                <a:solidFill>
+                  <a:srgbClr val="047857"/>
+                </a:solidFill>
+              </a:defRPr>
+            </a:pPr>
             <a:r>
               <a:t>Executive Summary</a:t>
             </a:r>
@@ -10821,6 +11194,41 @@
                 </a:solidFill>
               </a:defRPr>
             </a:pPr>
+          </a:p>
+        </p:txBody>
+      </p:sp>
+      <p:sp>
+        <p:nvSpPr>
+          <p:cNvPr id="76" name="TextBox 75"/>
+          <p:cNvSpPr txBox="1"/>
+          <p:nvPr/>
+        </p:nvSpPr>
+        <p:spPr>
+          <a:xfrm>
+            <a:off x="731520" y="1097280"/>
+            <a:ext cx="7680960" cy="4572000"/>
+          </a:xfrm>
+          <a:prstGeom prst="rect">
+            <a:avLst/>
+          </a:prstGeom>
+          <a:noFill/>
+        </p:spPr>
+        <p:txBody>
+          <a:bodyPr wrap="square">
+            <a:spAutoFit/>
+          </a:bodyPr>
+          <a:lstStyle/>
+          <a:p>
+            <a:pPr>
+              <a:spcAft>
+                <a:spcPts val="1200"/>
+              </a:spcAft>
+              <a:defRPr b="1" sz="2000">
+                <a:solidFill>
+                  <a:srgbClr val="047857"/>
+                </a:solidFill>
+              </a:defRPr>
+            </a:pPr>
             <a:r>
               <a:t>Brief About the Idea — EcoLoop AI</a:t>
             </a:r>
@@ -11196,6 +11604,41 @@
                 </a:solidFill>
               </a:defRPr>
             </a:pPr>
+          </a:p>
+        </p:txBody>
+      </p:sp>
+      <p:sp>
+        <p:nvSpPr>
+          <p:cNvPr id="84" name="TextBox 83"/>
+          <p:cNvSpPr txBox="1"/>
+          <p:nvPr/>
+        </p:nvSpPr>
+        <p:spPr>
+          <a:xfrm>
+            <a:off x="731520" y="1097280"/>
+            <a:ext cx="7680960" cy="4572000"/>
+          </a:xfrm>
+          <a:prstGeom prst="rect">
+            <a:avLst/>
+          </a:prstGeom>
+          <a:noFill/>
+        </p:spPr>
+        <p:txBody>
+          <a:bodyPr wrap="square">
+            <a:spAutoFit/>
+          </a:bodyPr>
+          <a:lstStyle/>
+          <a:p>
+            <a:pPr>
+              <a:spcAft>
+                <a:spcPts val="1200"/>
+              </a:spcAft>
+              <a:defRPr b="1" sz="2000">
+                <a:solidFill>
+                  <a:srgbClr val="047857"/>
+                </a:solidFill>
+              </a:defRPr>
+            </a:pPr>
             <a:r>
               <a:t>Opportunities &amp; Unique Selling Proposition (USP)</a:t>
             </a:r>
@@ -11617,6 +12060,41 @@
                 </a:solidFill>
               </a:defRPr>
             </a:pPr>
+          </a:p>
+        </p:txBody>
+      </p:sp>
+      <p:sp>
+        <p:nvSpPr>
+          <p:cNvPr id="92" name="TextBox 91"/>
+          <p:cNvSpPr txBox="1"/>
+          <p:nvPr/>
+        </p:nvSpPr>
+        <p:spPr>
+          <a:xfrm>
+            <a:off x="731520" y="1097280"/>
+            <a:ext cx="7680960" cy="4572000"/>
+          </a:xfrm>
+          <a:prstGeom prst="rect">
+            <a:avLst/>
+          </a:prstGeom>
+          <a:noFill/>
+        </p:spPr>
+        <p:txBody>
+          <a:bodyPr wrap="square">
+            <a:spAutoFit/>
+          </a:bodyPr>
+          <a:lstStyle/>
+          <a:p>
+            <a:pPr>
+              <a:spcAft>
+                <a:spcPts val="1200"/>
+              </a:spcAft>
+              <a:defRPr b="1" sz="2000">
+                <a:solidFill>
+                  <a:srgbClr val="047857"/>
+                </a:solidFill>
+              </a:defRPr>
+            </a:pPr>
             <a:r>
               <a:t>Key Features Offered by EcoLoop AI</a:t>
             </a:r>
@@ -12084,6 +12562,41 @@
                 </a:solidFill>
               </a:defRPr>
             </a:pPr>
+          </a:p>
+        </p:txBody>
+      </p:sp>
+      <p:sp>
+        <p:nvSpPr>
+          <p:cNvPr id="100" name="TextBox 99"/>
+          <p:cNvSpPr txBox="1"/>
+          <p:nvPr/>
+        </p:nvSpPr>
+        <p:spPr>
+          <a:xfrm>
+            <a:off x="731520" y="1097280"/>
+            <a:ext cx="7680960" cy="4572000"/>
+          </a:xfrm>
+          <a:prstGeom prst="rect">
+            <a:avLst/>
+          </a:prstGeom>
+          <a:noFill/>
+        </p:spPr>
+        <p:txBody>
+          <a:bodyPr wrap="square">
+            <a:spAutoFit/>
+          </a:bodyPr>
+          <a:lstStyle/>
+          <a:p>
+            <a:pPr>
+              <a:spcAft>
+                <a:spcPts val="1200"/>
+              </a:spcAft>
+              <a:defRPr b="1" sz="2000">
+                <a:solidFill>
+                  <a:srgbClr val="047857"/>
+                </a:solidFill>
+              </a:defRPr>
+            </a:pPr>
             <a:r>
               <a:t>Process Flow &amp; Use-Case Diagram</a:t>
             </a:r>
@@ -12647,124 +13160,6 @@
                 </a:solidFill>
               </a:defRPr>
             </a:pPr>
-            <a:r>
-              <a:t>UI Wireframes &amp; Component Hierarchy</a:t>
-            </a:r>
-          </a:p>
-          <a:p>
-            <a:pPr>
-              <a:spcAft>
-                <a:spcPts val="600"/>
-              </a:spcAft>
-            </a:pPr>
-            <a:r>
-              <a:rPr b="1" sz="1300">
-                <a:solidFill>
-                  <a:srgbClr val="1E293B"/>
-                </a:solidFill>
-              </a:rPr>
-              <a:t>• View 1 - AI Waste Scanner: </a:t>
-            </a:r>
-            <a:r>
-              <a:rPr sz="1300">
-                <a:solidFill>
-                  <a:srgbClr val="1E293B"/>
-                </a:solidFill>
-              </a:rPr>
-              <a:t>Hero banner, sample selector (Milma pouch, PET bottle, box, battery), real-time reasoning ticker.</a:t>
-            </a:r>
-          </a:p>
-          <a:p>
-            <a:pPr>
-              <a:spcAft>
-                <a:spcPts val="600"/>
-              </a:spcAft>
-            </a:pPr>
-            <a:r>
-              <a:rPr b="1" sz="1300">
-                <a:solidFill>
-                  <a:srgbClr val="1E293B"/>
-                </a:solidFill>
-              </a:rPr>
-              <a:t>• View 2 - Dynamic Guidance Card: </a:t>
-            </a:r>
-            <a:r>
-              <a:rPr sz="1300">
-                <a:solidFill>
-                  <a:srgbClr val="1E293B"/>
-                </a:solidFill>
-              </a:rPr>
-              <a:t>Certainty score badge, contamination alert, Suchitwa Mission cleaning/drying steps.</a:t>
-            </a:r>
-          </a:p>
-          <a:p>
-            <a:pPr>
-              <a:spcAft>
-                <a:spcPts val="600"/>
-              </a:spcAft>
-            </a:pPr>
-            <a:r>
-              <a:rPr b="1" sz="1300">
-                <a:solidFill>
-                  <a:srgbClr val="1E293B"/>
-                </a:solidFill>
-              </a:rPr>
-              <a:t>• View 3 - Kerala Recovery Hubs: </a:t>
-            </a:r>
-            <a:r>
-              <a:rPr sz="1300">
-                <a:solidFill>
-                  <a:srgbClr val="1E293B"/>
-                </a:solidFill>
-              </a:rPr>
-              <a:t>District and material category filters, collection calendars, facility addresses.</a:t>
-            </a:r>
-          </a:p>
-          <a:p>
-            <a:pPr>
-              <a:spcAft>
-                <a:spcPts val="600"/>
-              </a:spcAft>
-            </a:pPr>
-            <a:r>
-              <a:rPr b="1" sz="1300">
-                <a:solidFill>
-                  <a:srgbClr val="1E293B"/>
-                </a:solidFill>
-              </a:rPr>
-              <a:t>• View 4 - Collector Portal: </a:t>
-            </a:r>
-            <a:r>
-              <a:rPr sz="1300">
-                <a:solidFill>
-                  <a:srgbClr val="1E293B"/>
-                </a:solidFill>
-              </a:rPr>
-              <a:t>PIN-gated queue of pending pickups, certified scale weight entry, tamper-evident receipts.</a:t>
-            </a:r>
-          </a:p>
-          <a:p>
-            <a:pPr>
-              <a:spcAft>
-                <a:spcPts val="600"/>
-              </a:spcAft>
-            </a:pPr>
-            <a:r>
-              <a:rPr b="1" sz="1300">
-                <a:solidFill>
-                  <a:srgbClr val="1E293B"/>
-                </a:solidFill>
-              </a:rPr>
-              <a:t>• View 5 - Impact Ledger: </a:t>
-            </a:r>
-            <a:r>
-              <a:rPr sz="1300">
-                <a:solidFill>
-                  <a:srgbClr val="1E293B"/>
-                </a:solidFill>
-              </a:rPr>
-              <a:t>Verified landfill kg diverted, avoided CO2e, and live auditable handover feed.</a:t>
-            </a:r>
           </a:p>
         </p:txBody>
       </p:sp>
@@ -12795,6 +13190,207 @@
       <p:pic>
         <p:nvPicPr>
           <p:cNvPr id="113" name="Picture 112" descr="image.png"/>
+          <p:cNvPicPr>
+            <a:picLocks noChangeAspect="1"/>
+          </p:cNvPicPr>
+          <p:nvPr/>
+        </p:nvPicPr>
+        <p:blipFill>
+          <a:blip r:embed="rId6"/>
+          <a:stretch>
+            <a:fillRect/>
+          </a:stretch>
+        </p:blipFill>
+        <p:spPr>
+          <a:xfrm>
+            <a:off x="4754880" y="2926080"/>
+            <a:ext cx="3931920" cy="1828800"/>
+          </a:xfrm>
+          <a:prstGeom prst="rect">
+            <a:avLst/>
+          </a:prstGeom>
+        </p:spPr>
+      </p:pic>
+      <p:sp>
+        <p:nvSpPr>
+          <p:cNvPr id="114" name="TextBox 113"/>
+          <p:cNvSpPr txBox="1"/>
+          <p:nvPr/>
+        </p:nvSpPr>
+        <p:spPr>
+          <a:xfrm>
+            <a:off x="548640" y="914400"/>
+            <a:ext cx="4023360" cy="4023360"/>
+          </a:xfrm>
+          <a:prstGeom prst="rect">
+            <a:avLst/>
+          </a:prstGeom>
+          <a:noFill/>
+        </p:spPr>
+        <p:txBody>
+          <a:bodyPr wrap="square">
+            <a:spAutoFit/>
+          </a:bodyPr>
+          <a:lstStyle/>
+          <a:p>
+            <a:pPr>
+              <a:spcAft>
+                <a:spcPts val="1200"/>
+              </a:spcAft>
+              <a:defRPr b="1" sz="2000">
+                <a:solidFill>
+                  <a:srgbClr val="047857"/>
+                </a:solidFill>
+              </a:defRPr>
+            </a:pPr>
+            <a:r>
+              <a:t>UI Wireframes &amp; Component Hierarchy</a:t>
+            </a:r>
+          </a:p>
+          <a:p>
+            <a:pPr>
+              <a:spcAft>
+                <a:spcPts val="600"/>
+              </a:spcAft>
+            </a:pPr>
+            <a:r>
+              <a:rPr b="1" sz="1300">
+                <a:solidFill>
+                  <a:srgbClr val="1E293B"/>
+                </a:solidFill>
+              </a:rPr>
+              <a:t>• View 1 - AI Waste Scanner: </a:t>
+            </a:r>
+            <a:r>
+              <a:rPr sz="1300">
+                <a:solidFill>
+                  <a:srgbClr val="1E293B"/>
+                </a:solidFill>
+              </a:rPr>
+              <a:t>Hero banner, sample selector (Milma pouch, PET bottle, box, battery), real-time reasoning ticker.</a:t>
+            </a:r>
+          </a:p>
+          <a:p>
+            <a:pPr>
+              <a:spcAft>
+                <a:spcPts val="600"/>
+              </a:spcAft>
+            </a:pPr>
+            <a:r>
+              <a:rPr b="1" sz="1300">
+                <a:solidFill>
+                  <a:srgbClr val="1E293B"/>
+                </a:solidFill>
+              </a:rPr>
+              <a:t>• View 2 - Dynamic Guidance Card: </a:t>
+            </a:r>
+            <a:r>
+              <a:rPr sz="1300">
+                <a:solidFill>
+                  <a:srgbClr val="1E293B"/>
+                </a:solidFill>
+              </a:rPr>
+              <a:t>Certainty score badge, contamination alert, Suchitwa Mission cleaning/drying steps.</a:t>
+            </a:r>
+          </a:p>
+          <a:p>
+            <a:pPr>
+              <a:spcAft>
+                <a:spcPts val="600"/>
+              </a:spcAft>
+            </a:pPr>
+            <a:r>
+              <a:rPr b="1" sz="1300">
+                <a:solidFill>
+                  <a:srgbClr val="1E293B"/>
+                </a:solidFill>
+              </a:rPr>
+              <a:t>• View 3 - Kerala Recovery Hubs: </a:t>
+            </a:r>
+            <a:r>
+              <a:rPr sz="1300">
+                <a:solidFill>
+                  <a:srgbClr val="1E293B"/>
+                </a:solidFill>
+              </a:rPr>
+              <a:t>District and material category filters, collection calendars, facility addresses.</a:t>
+            </a:r>
+          </a:p>
+          <a:p>
+            <a:pPr>
+              <a:spcAft>
+                <a:spcPts val="600"/>
+              </a:spcAft>
+            </a:pPr>
+            <a:r>
+              <a:rPr b="1" sz="1300">
+                <a:solidFill>
+                  <a:srgbClr val="1E293B"/>
+                </a:solidFill>
+              </a:rPr>
+              <a:t>• View 4 - Collector Portal: </a:t>
+            </a:r>
+            <a:r>
+              <a:rPr sz="1300">
+                <a:solidFill>
+                  <a:srgbClr val="1E293B"/>
+                </a:solidFill>
+              </a:rPr>
+              <a:t>PIN-gated queue of pending pickups, certified scale weight entry, tamper-evident receipts.</a:t>
+            </a:r>
+          </a:p>
+          <a:p>
+            <a:pPr>
+              <a:spcAft>
+                <a:spcPts val="600"/>
+              </a:spcAft>
+            </a:pPr>
+            <a:r>
+              <a:rPr b="1" sz="1300">
+                <a:solidFill>
+                  <a:srgbClr val="1E293B"/>
+                </a:solidFill>
+              </a:rPr>
+              <a:t>• View 5 - Impact Ledger: </a:t>
+            </a:r>
+            <a:r>
+              <a:rPr sz="1300">
+                <a:solidFill>
+                  <a:srgbClr val="1E293B"/>
+                </a:solidFill>
+              </a:rPr>
+              <a:t>Verified landfill kg diverted, avoided CO2e, and live auditable handover feed.</a:t>
+            </a:r>
+          </a:p>
+        </p:txBody>
+      </p:sp>
+      <p:pic>
+        <p:nvPicPr>
+          <p:cNvPr id="115" name="Picture 114" descr="image.png"/>
+          <p:cNvPicPr>
+            <a:picLocks noChangeAspect="1"/>
+          </p:cNvPicPr>
+          <p:nvPr/>
+        </p:nvPicPr>
+        <p:blipFill>
+          <a:blip r:embed="rId5"/>
+          <a:stretch>
+            <a:fillRect/>
+          </a:stretch>
+        </p:blipFill>
+        <p:spPr>
+          <a:xfrm>
+            <a:off x="4754880" y="914400"/>
+            <a:ext cx="3931920" cy="1828800"/>
+          </a:xfrm>
+          <a:prstGeom prst="rect">
+            <a:avLst/>
+          </a:prstGeom>
+        </p:spPr>
+      </p:pic>
+      <p:pic>
+        <p:nvPicPr>
+          <p:cNvPr id="116" name="Picture 115" descr="image.png"/>
           <p:cNvPicPr>
             <a:picLocks noChangeAspect="1"/>
           </p:cNvPicPr>
@@ -13116,6 +13712,41 @@
                 </a:solidFill>
               </a:defRPr>
             </a:pPr>
+          </a:p>
+        </p:txBody>
+      </p:sp>
+      <p:sp>
+        <p:nvSpPr>
+          <p:cNvPr id="116" name="TextBox 115"/>
+          <p:cNvSpPr txBox="1"/>
+          <p:nvPr/>
+        </p:nvSpPr>
+        <p:spPr>
+          <a:xfrm>
+            <a:off x="731520" y="1097280"/>
+            <a:ext cx="7680960" cy="4572000"/>
+          </a:xfrm>
+          <a:prstGeom prst="rect">
+            <a:avLst/>
+          </a:prstGeom>
+          <a:noFill/>
+        </p:spPr>
+        <p:txBody>
+          <a:bodyPr wrap="square">
+            <a:spAutoFit/>
+          </a:bodyPr>
+          <a:lstStyle/>
+          <a:p>
+            <a:pPr>
+              <a:spcAft>
+                <a:spcPts val="1200"/>
+              </a:spcAft>
+              <a:defRPr b="1" sz="2000">
+                <a:solidFill>
+                  <a:srgbClr val="047857"/>
+                </a:solidFill>
+              </a:defRPr>
+            </a:pPr>
             <a:r>
               <a:t>System Architecture Diagram</a:t>
             </a:r>
@@ -13531,6 +14162,41 @@
       <p:sp>
         <p:nvSpPr>
           <p:cNvPr id="123" name="TextBox 122"/>
+          <p:cNvSpPr txBox="1"/>
+          <p:nvPr/>
+        </p:nvSpPr>
+        <p:spPr>
+          <a:xfrm>
+            <a:off x="731520" y="1097280"/>
+            <a:ext cx="7680960" cy="4572000"/>
+          </a:xfrm>
+          <a:prstGeom prst="rect">
+            <a:avLst/>
+          </a:prstGeom>
+          <a:noFill/>
+        </p:spPr>
+        <p:txBody>
+          <a:bodyPr wrap="square">
+            <a:spAutoFit/>
+          </a:bodyPr>
+          <a:lstStyle/>
+          <a:p>
+            <a:pPr>
+              <a:spcAft>
+                <a:spcPts val="1200"/>
+              </a:spcAft>
+              <a:defRPr b="1" sz="2000">
+                <a:solidFill>
+                  <a:srgbClr val="047857"/>
+                </a:solidFill>
+              </a:defRPr>
+            </a:pPr>
+          </a:p>
+        </p:txBody>
+      </p:sp>
+      <p:sp>
+        <p:nvSpPr>
+          <p:cNvPr id="124" name="TextBox 123"/>
           <p:cNvSpPr txBox="1"/>
           <p:nvPr/>
         </p:nvSpPr>

</xml_diff>

<commit_message>
fix(ui): overhaul navbar responsiveness, sample cards, and deep-link tab synchronization
</commit_message>
<xml_diff>
--- a/docs/EcoLoop_AI_Pitch_Deck.pptx
+++ b/docs/EcoLoop_AI_Pitch_Deck.pptx
@@ -7524,6 +7524,41 @@
                 </a:solidFill>
               </a:defRPr>
             </a:pPr>
+          </a:p>
+        </p:txBody>
+      </p:sp>
+      <p:sp>
+        <p:nvSpPr>
+          <p:cNvPr id="133" name="TextBox 132"/>
+          <p:cNvSpPr txBox="1"/>
+          <p:nvPr/>
+        </p:nvSpPr>
+        <p:spPr>
+          <a:xfrm>
+            <a:off x="731520" y="1097280"/>
+            <a:ext cx="7680960" cy="4572000"/>
+          </a:xfrm>
+          <a:prstGeom prst="rect">
+            <a:avLst/>
+          </a:prstGeom>
+          <a:noFill/>
+        </p:spPr>
+        <p:txBody>
+          <a:bodyPr wrap="square">
+            <a:spAutoFit/>
+          </a:bodyPr>
+          <a:lstStyle/>
+          <a:p>
+            <a:pPr>
+              <a:spcAft>
+                <a:spcPts val="1200"/>
+              </a:spcAft>
+              <a:defRPr b="1" sz="2000">
+                <a:solidFill>
+                  <a:srgbClr val="047857"/>
+                </a:solidFill>
+              </a:defRPr>
+            </a:pPr>
             <a:r>
               <a:t>Estimated Implementation &amp; Operating Cost</a:t>
             </a:r>
@@ -8256,21 +8291,6 @@
                 </a:solidFill>
               </a:defRPr>
             </a:pPr>
-            <a:r>
-              <a:t>Snapshots of the Working Prototype</a:t>
-            </a:r>
-          </a:p>
-          <a:p>
-            <a:pPr>
-              <a:defRPr sz="1100">
-                <a:solidFill>
-                  <a:srgbClr val="64748B"/>
-                </a:solidFill>
-              </a:defRPr>
-            </a:pPr>
-            <a:r>
-              <a:t>Multimodal Gemini 2.5 Scanner • Malayalam Localization • Collector Portal • Auditable Impact Ledger</a:t>
-            </a:r>
           </a:p>
         </p:txBody>
       </p:sp>
@@ -8356,6 +8376,149 @@
         </p:nvPicPr>
         <p:blipFill>
           <a:blip r:embed="rId8"/>
+          <a:stretch>
+            <a:fillRect/>
+          </a:stretch>
+        </p:blipFill>
+        <p:spPr>
+          <a:xfrm>
+            <a:off x="4663440" y="3108960"/>
+            <a:ext cx="3840480" cy="1783080"/>
+          </a:xfrm>
+          <a:prstGeom prst="rect">
+            <a:avLst/>
+          </a:prstGeom>
+        </p:spPr>
+      </p:pic>
+      <p:sp>
+        <p:nvSpPr>
+          <p:cNvPr id="157" name="TextBox 156"/>
+          <p:cNvSpPr txBox="1"/>
+          <p:nvPr/>
+        </p:nvSpPr>
+        <p:spPr>
+          <a:xfrm>
+            <a:off x="548640" y="365760"/>
+            <a:ext cx="8046720" cy="731520"/>
+          </a:xfrm>
+          <a:prstGeom prst="rect">
+            <a:avLst/>
+          </a:prstGeom>
+          <a:noFill/>
+        </p:spPr>
+        <p:txBody>
+          <a:bodyPr wrap="square">
+            <a:spAutoFit/>
+          </a:bodyPr>
+          <a:lstStyle/>
+          <a:p>
+            <a:pPr>
+              <a:defRPr b="1" sz="2200">
+                <a:solidFill>
+                  <a:srgbClr val="047857"/>
+                </a:solidFill>
+              </a:defRPr>
+            </a:pPr>
+            <a:r>
+              <a:t>Snapshots of the Working Prototype</a:t>
+            </a:r>
+          </a:p>
+          <a:p>
+            <a:pPr>
+              <a:defRPr sz="1100">
+                <a:solidFill>
+                  <a:srgbClr val="64748B"/>
+                </a:solidFill>
+              </a:defRPr>
+            </a:pPr>
+            <a:r>
+              <a:t>Multimodal Gemini 2.5 Scanner • Malayalam Localization • Collector Portal • Auditable Impact Ledger</a:t>
+            </a:r>
+          </a:p>
+        </p:txBody>
+      </p:sp>
+      <p:pic>
+        <p:nvPicPr>
+          <p:cNvPr id="158" name="Picture 157" descr="image.png"/>
+          <p:cNvPicPr>
+            <a:picLocks noChangeAspect="1"/>
+          </p:cNvPicPr>
+          <p:nvPr/>
+        </p:nvPicPr>
+        <p:blipFill>
+          <a:blip r:embed="rId5"/>
+          <a:stretch>
+            <a:fillRect/>
+          </a:stretch>
+        </p:blipFill>
+        <p:spPr>
+          <a:xfrm>
+            <a:off x="548640" y="1188720"/>
+            <a:ext cx="3840480" cy="1783080"/>
+          </a:xfrm>
+          <a:prstGeom prst="rect">
+            <a:avLst/>
+          </a:prstGeom>
+        </p:spPr>
+      </p:pic>
+      <p:pic>
+        <p:nvPicPr>
+          <p:cNvPr id="159" name="Picture 158" descr="image.png"/>
+          <p:cNvPicPr>
+            <a:picLocks noChangeAspect="1"/>
+          </p:cNvPicPr>
+          <p:nvPr/>
+        </p:nvPicPr>
+        <p:blipFill>
+          <a:blip r:embed="rId6"/>
+          <a:stretch>
+            <a:fillRect/>
+          </a:stretch>
+        </p:blipFill>
+        <p:spPr>
+          <a:xfrm>
+            <a:off x="4663440" y="1188720"/>
+            <a:ext cx="3840480" cy="1783080"/>
+          </a:xfrm>
+          <a:prstGeom prst="rect">
+            <a:avLst/>
+          </a:prstGeom>
+        </p:spPr>
+      </p:pic>
+      <p:pic>
+        <p:nvPicPr>
+          <p:cNvPr id="160" name="Picture 159" descr="collector_portal_view_1792332842110.png"/>
+          <p:cNvPicPr>
+            <a:picLocks noChangeAspect="1"/>
+          </p:cNvPicPr>
+          <p:nvPr/>
+        </p:nvPicPr>
+        <p:blipFill>
+          <a:blip r:embed="rId9"/>
+          <a:stretch>
+            <a:fillRect/>
+          </a:stretch>
+        </p:blipFill>
+        <p:spPr>
+          <a:xfrm>
+            <a:off x="548640" y="3108960"/>
+            <a:ext cx="3840480" cy="1783080"/>
+          </a:xfrm>
+          <a:prstGeom prst="rect">
+            <a:avLst/>
+          </a:prstGeom>
+        </p:spPr>
+      </p:pic>
+      <p:pic>
+        <p:nvPicPr>
+          <p:cNvPr id="161" name="Picture 160" descr="impact_dashboard_metrics_1792332824611.png"/>
+          <p:cNvPicPr>
+            <a:picLocks noChangeAspect="1"/>
+          </p:cNvPicPr>
+          <p:nvPr/>
+        </p:nvPicPr>
+        <p:blipFill>
+          <a:blip r:embed="rId10"/>
           <a:stretch>
             <a:fillRect/>
           </a:stretch>
@@ -8705,6 +8868,41 @@
                 </a:solidFill>
               </a:defRPr>
             </a:pPr>
+          </a:p>
+        </p:txBody>
+      </p:sp>
+      <p:sp>
+        <p:nvSpPr>
+          <p:cNvPr id="149" name="TextBox 148"/>
+          <p:cNvSpPr txBox="1"/>
+          <p:nvPr/>
+        </p:nvSpPr>
+        <p:spPr>
+          <a:xfrm>
+            <a:off x="731520" y="1097280"/>
+            <a:ext cx="7680960" cy="4572000"/>
+          </a:xfrm>
+          <a:prstGeom prst="rect">
+            <a:avLst/>
+          </a:prstGeom>
+          <a:noFill/>
+        </p:spPr>
+        <p:txBody>
+          <a:bodyPr wrap="square">
+            <a:spAutoFit/>
+          </a:bodyPr>
+          <a:lstStyle/>
+          <a:p>
+            <a:pPr>
+              <a:spcAft>
+                <a:spcPts val="1200"/>
+              </a:spcAft>
+              <a:defRPr b="1" sz="2000">
+                <a:solidFill>
+                  <a:srgbClr val="047857"/>
+                </a:solidFill>
+              </a:defRPr>
+            </a:pPr>
             <a:r>
               <a:t>Prototype Performance &amp; Quality Benchmarks</a:t>
             </a:r>
@@ -9161,6 +9359,41 @@
                 </a:solidFill>
               </a:defRPr>
             </a:pPr>
+          </a:p>
+        </p:txBody>
+      </p:sp>
+      <p:sp>
+        <p:nvSpPr>
+          <p:cNvPr id="157" name="TextBox 156"/>
+          <p:cNvSpPr txBox="1"/>
+          <p:nvPr/>
+        </p:nvSpPr>
+        <p:spPr>
+          <a:xfrm>
+            <a:off x="731520" y="1097280"/>
+            <a:ext cx="7680960" cy="4572000"/>
+          </a:xfrm>
+          <a:prstGeom prst="rect">
+            <a:avLst/>
+          </a:prstGeom>
+          <a:noFill/>
+        </p:spPr>
+        <p:txBody>
+          <a:bodyPr wrap="square">
+            <a:spAutoFit/>
+          </a:bodyPr>
+          <a:lstStyle/>
+          <a:p>
+            <a:pPr>
+              <a:spcAft>
+                <a:spcPts val="1200"/>
+              </a:spcAft>
+              <a:defRPr b="1" sz="2000">
+                <a:solidFill>
+                  <a:srgbClr val="047857"/>
+                </a:solidFill>
+              </a:defRPr>
+            </a:pPr>
             <a:r>
               <a:t>Future Development &amp; Commercial Roadmap</a:t>
             </a:r>
@@ -9594,6 +9827,41 @@
                 </a:solidFill>
               </a:defRPr>
             </a:pPr>
+          </a:p>
+        </p:txBody>
+      </p:sp>
+      <p:sp>
+        <p:nvSpPr>
+          <p:cNvPr id="165" name="TextBox 164"/>
+          <p:cNvSpPr txBox="1"/>
+          <p:nvPr/>
+        </p:nvSpPr>
+        <p:spPr>
+          <a:xfrm>
+            <a:off x="731520" y="914400"/>
+            <a:ext cx="7680960" cy="4572000"/>
+          </a:xfrm>
+          <a:prstGeom prst="rect">
+            <a:avLst/>
+          </a:prstGeom>
+          <a:noFill/>
+        </p:spPr>
+        <p:txBody>
+          <a:bodyPr wrap="square">
+            <a:spAutoFit/>
+          </a:bodyPr>
+          <a:lstStyle/>
+          <a:p>
+            <a:pPr>
+              <a:spcAft>
+                <a:spcPts val="1200"/>
+              </a:spcAft>
+              <a:defRPr b="1" sz="2000">
+                <a:solidFill>
+                  <a:srgbClr val="047857"/>
+                </a:solidFill>
+              </a:defRPr>
+            </a:pPr>
             <a:r>
               <a:t>Official Submission Links</a:t>
             </a:r>
@@ -10076,6 +10344,41 @@
                 </a:solidFill>
               </a:defRPr>
             </a:pPr>
+          </a:p>
+        </p:txBody>
+      </p:sp>
+      <p:sp>
+        <p:nvSpPr>
+          <p:cNvPr id="172" name="TextBox 171"/>
+          <p:cNvSpPr txBox="1"/>
+          <p:nvPr/>
+        </p:nvSpPr>
+        <p:spPr>
+          <a:xfrm>
+            <a:off x="731520" y="1097280"/>
+            <a:ext cx="7680960" cy="4572000"/>
+          </a:xfrm>
+          <a:prstGeom prst="rect">
+            <a:avLst/>
+          </a:prstGeom>
+          <a:noFill/>
+        </p:spPr>
+        <p:txBody>
+          <a:bodyPr wrap="square">
+            <a:spAutoFit/>
+          </a:bodyPr>
+          <a:lstStyle/>
+          <a:p>
+            <a:pPr>
+              <a:spcAft>
+                <a:spcPts val="1200"/>
+              </a:spcAft>
+              <a:defRPr b="1" sz="2000">
+                <a:solidFill>
+                  <a:srgbClr val="047857"/>
+                </a:solidFill>
+              </a:defRPr>
+            </a:pPr>
             <a:r>
               <a:t>Why EcoLoop AI Wins the AI Builder Cup</a:t>
             </a:r>
@@ -10426,6 +10729,41 @@
                 </a:solidFill>
               </a:defRPr>
             </a:pPr>
+          </a:p>
+        </p:txBody>
+      </p:sp>
+      <p:sp>
+        <p:nvSpPr>
+          <p:cNvPr id="178" name="TextBox 177"/>
+          <p:cNvSpPr txBox="1"/>
+          <p:nvPr/>
+        </p:nvSpPr>
+        <p:spPr>
+          <a:xfrm>
+            <a:off x="1371600" y="2011680"/>
+            <a:ext cx="6400800" cy="2743200"/>
+          </a:xfrm>
+          <a:prstGeom prst="rect">
+            <a:avLst/>
+          </a:prstGeom>
+          <a:noFill/>
+        </p:spPr>
+        <p:txBody>
+          <a:bodyPr wrap="square">
+            <a:spAutoFit/>
+          </a:bodyPr>
+          <a:lstStyle/>
+          <a:p>
+            <a:pPr>
+              <a:spcAft>
+                <a:spcPts val="1200"/>
+              </a:spcAft>
+              <a:defRPr b="1" sz="2000">
+                <a:solidFill>
+                  <a:srgbClr val="047857"/>
+                </a:solidFill>
+              </a:defRPr>
+            </a:pPr>
             <a:r>
               <a:t>EcoLoop AI — From Waste to Verified Value</a:t>
             </a:r>
@@ -10823,6 +11161,41 @@
                 </a:solidFill>
               </a:defRPr>
             </a:pPr>
+          </a:p>
+        </p:txBody>
+      </p:sp>
+      <p:sp>
+        <p:nvSpPr>
+          <p:cNvPr id="70" name="TextBox 69"/>
+          <p:cNvSpPr txBox="1"/>
+          <p:nvPr/>
+        </p:nvSpPr>
+        <p:spPr>
+          <a:xfrm>
+            <a:off x="731520" y="1097280"/>
+            <a:ext cx="7680960" cy="4572000"/>
+          </a:xfrm>
+          <a:prstGeom prst="rect">
+            <a:avLst/>
+          </a:prstGeom>
+          <a:noFill/>
+        </p:spPr>
+        <p:txBody>
+          <a:bodyPr wrap="square">
+            <a:spAutoFit/>
+          </a:bodyPr>
+          <a:lstStyle/>
+          <a:p>
+            <a:pPr>
+              <a:spcAft>
+                <a:spcPts val="1200"/>
+              </a:spcAft>
+              <a:defRPr b="1" sz="2000">
+                <a:solidFill>
+                  <a:srgbClr val="047857"/>
+                </a:solidFill>
+              </a:defRPr>
+            </a:pPr>
             <a:r>
               <a:t>Executive Summary</a:t>
             </a:r>
@@ -11229,6 +11602,41 @@
                 </a:solidFill>
               </a:defRPr>
             </a:pPr>
+          </a:p>
+        </p:txBody>
+      </p:sp>
+      <p:sp>
+        <p:nvSpPr>
+          <p:cNvPr id="77" name="TextBox 76"/>
+          <p:cNvSpPr txBox="1"/>
+          <p:nvPr/>
+        </p:nvSpPr>
+        <p:spPr>
+          <a:xfrm>
+            <a:off x="731520" y="1097280"/>
+            <a:ext cx="7680960" cy="4572000"/>
+          </a:xfrm>
+          <a:prstGeom prst="rect">
+            <a:avLst/>
+          </a:prstGeom>
+          <a:noFill/>
+        </p:spPr>
+        <p:txBody>
+          <a:bodyPr wrap="square">
+            <a:spAutoFit/>
+          </a:bodyPr>
+          <a:lstStyle/>
+          <a:p>
+            <a:pPr>
+              <a:spcAft>
+                <a:spcPts val="1200"/>
+              </a:spcAft>
+              <a:defRPr b="1" sz="2000">
+                <a:solidFill>
+                  <a:srgbClr val="047857"/>
+                </a:solidFill>
+              </a:defRPr>
+            </a:pPr>
             <a:r>
               <a:t>Brief About the Idea — EcoLoop AI</a:t>
             </a:r>
@@ -11639,6 +12047,41 @@
                 </a:solidFill>
               </a:defRPr>
             </a:pPr>
+          </a:p>
+        </p:txBody>
+      </p:sp>
+      <p:sp>
+        <p:nvSpPr>
+          <p:cNvPr id="85" name="TextBox 84"/>
+          <p:cNvSpPr txBox="1"/>
+          <p:nvPr/>
+        </p:nvSpPr>
+        <p:spPr>
+          <a:xfrm>
+            <a:off x="731520" y="1097280"/>
+            <a:ext cx="7680960" cy="4572000"/>
+          </a:xfrm>
+          <a:prstGeom prst="rect">
+            <a:avLst/>
+          </a:prstGeom>
+          <a:noFill/>
+        </p:spPr>
+        <p:txBody>
+          <a:bodyPr wrap="square">
+            <a:spAutoFit/>
+          </a:bodyPr>
+          <a:lstStyle/>
+          <a:p>
+            <a:pPr>
+              <a:spcAft>
+                <a:spcPts val="1200"/>
+              </a:spcAft>
+              <a:defRPr b="1" sz="2000">
+                <a:solidFill>
+                  <a:srgbClr val="047857"/>
+                </a:solidFill>
+              </a:defRPr>
+            </a:pPr>
             <a:r>
               <a:t>Opportunities &amp; Unique Selling Proposition (USP)</a:t>
             </a:r>
@@ -12095,6 +12538,41 @@
                 </a:solidFill>
               </a:defRPr>
             </a:pPr>
+          </a:p>
+        </p:txBody>
+      </p:sp>
+      <p:sp>
+        <p:nvSpPr>
+          <p:cNvPr id="93" name="TextBox 92"/>
+          <p:cNvSpPr txBox="1"/>
+          <p:nvPr/>
+        </p:nvSpPr>
+        <p:spPr>
+          <a:xfrm>
+            <a:off x="731520" y="1097280"/>
+            <a:ext cx="7680960" cy="4572000"/>
+          </a:xfrm>
+          <a:prstGeom prst="rect">
+            <a:avLst/>
+          </a:prstGeom>
+          <a:noFill/>
+        </p:spPr>
+        <p:txBody>
+          <a:bodyPr wrap="square">
+            <a:spAutoFit/>
+          </a:bodyPr>
+          <a:lstStyle/>
+          <a:p>
+            <a:pPr>
+              <a:spcAft>
+                <a:spcPts val="1200"/>
+              </a:spcAft>
+              <a:defRPr b="1" sz="2000">
+                <a:solidFill>
+                  <a:srgbClr val="047857"/>
+                </a:solidFill>
+              </a:defRPr>
+            </a:pPr>
             <a:r>
               <a:t>Key Features Offered by EcoLoop AI</a:t>
             </a:r>
@@ -12597,6 +13075,41 @@
                 </a:solidFill>
               </a:defRPr>
             </a:pPr>
+          </a:p>
+        </p:txBody>
+      </p:sp>
+      <p:sp>
+        <p:nvSpPr>
+          <p:cNvPr id="101" name="TextBox 100"/>
+          <p:cNvSpPr txBox="1"/>
+          <p:nvPr/>
+        </p:nvSpPr>
+        <p:spPr>
+          <a:xfrm>
+            <a:off x="731520" y="1097280"/>
+            <a:ext cx="7680960" cy="4572000"/>
+          </a:xfrm>
+          <a:prstGeom prst="rect">
+            <a:avLst/>
+          </a:prstGeom>
+          <a:noFill/>
+        </p:spPr>
+        <p:txBody>
+          <a:bodyPr wrap="square">
+            <a:spAutoFit/>
+          </a:bodyPr>
+          <a:lstStyle/>
+          <a:p>
+            <a:pPr>
+              <a:spcAft>
+                <a:spcPts val="1200"/>
+              </a:spcAft>
+              <a:defRPr b="1" sz="2000">
+                <a:solidFill>
+                  <a:srgbClr val="047857"/>
+                </a:solidFill>
+              </a:defRPr>
+            </a:pPr>
             <a:r>
               <a:t>Process Flow &amp; Use-Case Diagram</a:t>
             </a:r>
@@ -13243,124 +13756,6 @@
                 </a:solidFill>
               </a:defRPr>
             </a:pPr>
-            <a:r>
-              <a:t>UI Wireframes &amp; Component Hierarchy</a:t>
-            </a:r>
-          </a:p>
-          <a:p>
-            <a:pPr>
-              <a:spcAft>
-                <a:spcPts val="600"/>
-              </a:spcAft>
-            </a:pPr>
-            <a:r>
-              <a:rPr b="1" sz="1300">
-                <a:solidFill>
-                  <a:srgbClr val="1E293B"/>
-                </a:solidFill>
-              </a:rPr>
-              <a:t>• View 1 - AI Waste Scanner: </a:t>
-            </a:r>
-            <a:r>
-              <a:rPr sz="1300">
-                <a:solidFill>
-                  <a:srgbClr val="1E293B"/>
-                </a:solidFill>
-              </a:rPr>
-              <a:t>Hero banner, sample selector (Milma pouch, PET bottle, box, battery), real-time reasoning ticker.</a:t>
-            </a:r>
-          </a:p>
-          <a:p>
-            <a:pPr>
-              <a:spcAft>
-                <a:spcPts val="600"/>
-              </a:spcAft>
-            </a:pPr>
-            <a:r>
-              <a:rPr b="1" sz="1300">
-                <a:solidFill>
-                  <a:srgbClr val="1E293B"/>
-                </a:solidFill>
-              </a:rPr>
-              <a:t>• View 2 - Dynamic Guidance Card: </a:t>
-            </a:r>
-            <a:r>
-              <a:rPr sz="1300">
-                <a:solidFill>
-                  <a:srgbClr val="1E293B"/>
-                </a:solidFill>
-              </a:rPr>
-              <a:t>Certainty score badge, contamination alert, Suchitwa Mission cleaning/drying steps.</a:t>
-            </a:r>
-          </a:p>
-          <a:p>
-            <a:pPr>
-              <a:spcAft>
-                <a:spcPts val="600"/>
-              </a:spcAft>
-            </a:pPr>
-            <a:r>
-              <a:rPr b="1" sz="1300">
-                <a:solidFill>
-                  <a:srgbClr val="1E293B"/>
-                </a:solidFill>
-              </a:rPr>
-              <a:t>• View 3 - Kerala Recovery Hubs: </a:t>
-            </a:r>
-            <a:r>
-              <a:rPr sz="1300">
-                <a:solidFill>
-                  <a:srgbClr val="1E293B"/>
-                </a:solidFill>
-              </a:rPr>
-              <a:t>District and material category filters, collection calendars, facility addresses.</a:t>
-            </a:r>
-          </a:p>
-          <a:p>
-            <a:pPr>
-              <a:spcAft>
-                <a:spcPts val="600"/>
-              </a:spcAft>
-            </a:pPr>
-            <a:r>
-              <a:rPr b="1" sz="1300">
-                <a:solidFill>
-                  <a:srgbClr val="1E293B"/>
-                </a:solidFill>
-              </a:rPr>
-              <a:t>• View 4 - Collector Portal: </a:t>
-            </a:r>
-            <a:r>
-              <a:rPr sz="1300">
-                <a:solidFill>
-                  <a:srgbClr val="1E293B"/>
-                </a:solidFill>
-              </a:rPr>
-              <a:t>PIN-gated queue of pending pickups, certified scale weight entry, tamper-evident receipts.</a:t>
-            </a:r>
-          </a:p>
-          <a:p>
-            <a:pPr>
-              <a:spcAft>
-                <a:spcPts val="600"/>
-              </a:spcAft>
-            </a:pPr>
-            <a:r>
-              <a:rPr b="1" sz="1300">
-                <a:solidFill>
-                  <a:srgbClr val="1E293B"/>
-                </a:solidFill>
-              </a:rPr>
-              <a:t>• View 5 - Impact Ledger: </a:t>
-            </a:r>
-            <a:r>
-              <a:rPr sz="1300">
-                <a:solidFill>
-                  <a:srgbClr val="1E293B"/>
-                </a:solidFill>
-              </a:rPr>
-              <a:t>Verified landfill kg diverted, avoided CO2e, and live auditable handover feed.</a:t>
-            </a:r>
           </a:p>
         </p:txBody>
       </p:sp>
@@ -13391,6 +13786,207 @@
       <p:pic>
         <p:nvPicPr>
           <p:cNvPr id="116" name="Picture 115" descr="image.png"/>
+          <p:cNvPicPr>
+            <a:picLocks noChangeAspect="1"/>
+          </p:cNvPicPr>
+          <p:nvPr/>
+        </p:nvPicPr>
+        <p:blipFill>
+          <a:blip r:embed="rId6"/>
+          <a:stretch>
+            <a:fillRect/>
+          </a:stretch>
+        </p:blipFill>
+        <p:spPr>
+          <a:xfrm>
+            <a:off x="4754880" y="2926080"/>
+            <a:ext cx="3931920" cy="1828800"/>
+          </a:xfrm>
+          <a:prstGeom prst="rect">
+            <a:avLst/>
+          </a:prstGeom>
+        </p:spPr>
+      </p:pic>
+      <p:sp>
+        <p:nvSpPr>
+          <p:cNvPr id="117" name="TextBox 116"/>
+          <p:cNvSpPr txBox="1"/>
+          <p:nvPr/>
+        </p:nvSpPr>
+        <p:spPr>
+          <a:xfrm>
+            <a:off x="548640" y="914400"/>
+            <a:ext cx="4023360" cy="4023360"/>
+          </a:xfrm>
+          <a:prstGeom prst="rect">
+            <a:avLst/>
+          </a:prstGeom>
+          <a:noFill/>
+        </p:spPr>
+        <p:txBody>
+          <a:bodyPr wrap="square">
+            <a:spAutoFit/>
+          </a:bodyPr>
+          <a:lstStyle/>
+          <a:p>
+            <a:pPr>
+              <a:spcAft>
+                <a:spcPts val="1200"/>
+              </a:spcAft>
+              <a:defRPr b="1" sz="2000">
+                <a:solidFill>
+                  <a:srgbClr val="047857"/>
+                </a:solidFill>
+              </a:defRPr>
+            </a:pPr>
+            <a:r>
+              <a:t>UI Wireframes &amp; Component Hierarchy</a:t>
+            </a:r>
+          </a:p>
+          <a:p>
+            <a:pPr>
+              <a:spcAft>
+                <a:spcPts val="600"/>
+              </a:spcAft>
+            </a:pPr>
+            <a:r>
+              <a:rPr b="1" sz="1300">
+                <a:solidFill>
+                  <a:srgbClr val="1E293B"/>
+                </a:solidFill>
+              </a:rPr>
+              <a:t>• View 1 - AI Waste Scanner: </a:t>
+            </a:r>
+            <a:r>
+              <a:rPr sz="1300">
+                <a:solidFill>
+                  <a:srgbClr val="1E293B"/>
+                </a:solidFill>
+              </a:rPr>
+              <a:t>Hero banner, sample selector (Milma pouch, PET bottle, box, battery), real-time reasoning ticker.</a:t>
+            </a:r>
+          </a:p>
+          <a:p>
+            <a:pPr>
+              <a:spcAft>
+                <a:spcPts val="600"/>
+              </a:spcAft>
+            </a:pPr>
+            <a:r>
+              <a:rPr b="1" sz="1300">
+                <a:solidFill>
+                  <a:srgbClr val="1E293B"/>
+                </a:solidFill>
+              </a:rPr>
+              <a:t>• View 2 - Dynamic Guidance Card: </a:t>
+            </a:r>
+            <a:r>
+              <a:rPr sz="1300">
+                <a:solidFill>
+                  <a:srgbClr val="1E293B"/>
+                </a:solidFill>
+              </a:rPr>
+              <a:t>Certainty score badge, contamination alert, Suchitwa Mission cleaning/drying steps.</a:t>
+            </a:r>
+          </a:p>
+          <a:p>
+            <a:pPr>
+              <a:spcAft>
+                <a:spcPts val="600"/>
+              </a:spcAft>
+            </a:pPr>
+            <a:r>
+              <a:rPr b="1" sz="1300">
+                <a:solidFill>
+                  <a:srgbClr val="1E293B"/>
+                </a:solidFill>
+              </a:rPr>
+              <a:t>• View 3 - Kerala Recovery Hubs: </a:t>
+            </a:r>
+            <a:r>
+              <a:rPr sz="1300">
+                <a:solidFill>
+                  <a:srgbClr val="1E293B"/>
+                </a:solidFill>
+              </a:rPr>
+              <a:t>District and material category filters, collection calendars, facility addresses.</a:t>
+            </a:r>
+          </a:p>
+          <a:p>
+            <a:pPr>
+              <a:spcAft>
+                <a:spcPts val="600"/>
+              </a:spcAft>
+            </a:pPr>
+            <a:r>
+              <a:rPr b="1" sz="1300">
+                <a:solidFill>
+                  <a:srgbClr val="1E293B"/>
+                </a:solidFill>
+              </a:rPr>
+              <a:t>• View 4 - Collector Portal: </a:t>
+            </a:r>
+            <a:r>
+              <a:rPr sz="1300">
+                <a:solidFill>
+                  <a:srgbClr val="1E293B"/>
+                </a:solidFill>
+              </a:rPr>
+              <a:t>PIN-gated queue of pending pickups, certified scale weight entry, tamper-evident receipts.</a:t>
+            </a:r>
+          </a:p>
+          <a:p>
+            <a:pPr>
+              <a:spcAft>
+                <a:spcPts val="600"/>
+              </a:spcAft>
+            </a:pPr>
+            <a:r>
+              <a:rPr b="1" sz="1300">
+                <a:solidFill>
+                  <a:srgbClr val="1E293B"/>
+                </a:solidFill>
+              </a:rPr>
+              <a:t>• View 5 - Impact Ledger: </a:t>
+            </a:r>
+            <a:r>
+              <a:rPr sz="1300">
+                <a:solidFill>
+                  <a:srgbClr val="1E293B"/>
+                </a:solidFill>
+              </a:rPr>
+              <a:t>Verified landfill kg diverted, avoided CO2e, and live auditable handover feed.</a:t>
+            </a:r>
+          </a:p>
+        </p:txBody>
+      </p:sp>
+      <p:pic>
+        <p:nvPicPr>
+          <p:cNvPr id="118" name="Picture 117" descr="home_view_1792332736713.png"/>
+          <p:cNvPicPr>
+            <a:picLocks noChangeAspect="1"/>
+          </p:cNvPicPr>
+          <p:nvPr/>
+        </p:nvPicPr>
+        <p:blipFill>
+          <a:blip r:embed="rId7"/>
+          <a:stretch>
+            <a:fillRect/>
+          </a:stretch>
+        </p:blipFill>
+        <p:spPr>
+          <a:xfrm>
+            <a:off x="4754880" y="914400"/>
+            <a:ext cx="3931920" cy="1828800"/>
+          </a:xfrm>
+          <a:prstGeom prst="rect">
+            <a:avLst/>
+          </a:prstGeom>
+        </p:spPr>
+      </p:pic>
+      <p:pic>
+        <p:nvPicPr>
+          <p:cNvPr id="119" name="Picture 118" descr="image.png"/>
           <p:cNvPicPr>
             <a:picLocks noChangeAspect="1"/>
           </p:cNvPicPr>
@@ -13747,6 +14343,41 @@
                 </a:solidFill>
               </a:defRPr>
             </a:pPr>
+          </a:p>
+        </p:txBody>
+      </p:sp>
+      <p:sp>
+        <p:nvSpPr>
+          <p:cNvPr id="117" name="TextBox 116"/>
+          <p:cNvSpPr txBox="1"/>
+          <p:nvPr/>
+        </p:nvSpPr>
+        <p:spPr>
+          <a:xfrm>
+            <a:off x="731520" y="1097280"/>
+            <a:ext cx="7680960" cy="4572000"/>
+          </a:xfrm>
+          <a:prstGeom prst="rect">
+            <a:avLst/>
+          </a:prstGeom>
+          <a:noFill/>
+        </p:spPr>
+        <p:txBody>
+          <a:bodyPr wrap="square">
+            <a:spAutoFit/>
+          </a:bodyPr>
+          <a:lstStyle/>
+          <a:p>
+            <a:pPr>
+              <a:spcAft>
+                <a:spcPts val="1200"/>
+              </a:spcAft>
+              <a:defRPr b="1" sz="2000">
+                <a:solidFill>
+                  <a:srgbClr val="047857"/>
+                </a:solidFill>
+              </a:defRPr>
+            </a:pPr>
             <a:r>
               <a:t>System Architecture Diagram</a:t>
             </a:r>
@@ -14197,6 +14828,41 @@
       <p:sp>
         <p:nvSpPr>
           <p:cNvPr id="124" name="TextBox 123"/>
+          <p:cNvSpPr txBox="1"/>
+          <p:nvPr/>
+        </p:nvSpPr>
+        <p:spPr>
+          <a:xfrm>
+            <a:off x="731520" y="1097280"/>
+            <a:ext cx="7680960" cy="4572000"/>
+          </a:xfrm>
+          <a:prstGeom prst="rect">
+            <a:avLst/>
+          </a:prstGeom>
+          <a:noFill/>
+        </p:spPr>
+        <p:txBody>
+          <a:bodyPr wrap="square">
+            <a:spAutoFit/>
+          </a:bodyPr>
+          <a:lstStyle/>
+          <a:p>
+            <a:pPr>
+              <a:spcAft>
+                <a:spcPts val="1200"/>
+              </a:spcAft>
+              <a:defRPr b="1" sz="2000">
+                <a:solidFill>
+                  <a:srgbClr val="047857"/>
+                </a:solidFill>
+              </a:defRPr>
+            </a:pPr>
+          </a:p>
+        </p:txBody>
+      </p:sp>
+      <p:sp>
+        <p:nvSpPr>
+          <p:cNvPr id="125" name="TextBox 124"/>
           <p:cNvSpPr txBox="1"/>
           <p:nvPr/>
         </p:nvSpPr>

</xml_diff>